<commit_message>
chore: last touch to presentation
</commit_message>
<xml_diff>
--- a/presentation/final-finished.pptx
+++ b/presentation/final-finished.pptx
@@ -5,7 +5,7 @@
     <p:sldMasterId id="2147483648" r:id="rId1"/>
   </p:sldMasterIdLst>
   <p:notesMasterIdLst>
-    <p:notesMasterId r:id="rId10"/>
+    <p:notesMasterId r:id="rId12"/>
   </p:notesMasterIdLst>
   <p:sldIdLst>
     <p:sldId id="256" r:id="rId2"/>
@@ -16,6 +16,8 @@
     <p:sldId id="264" r:id="rId7"/>
     <p:sldId id="266" r:id="rId8"/>
     <p:sldId id="267" r:id="rId9"/>
+    <p:sldId id="258" r:id="rId10"/>
+    <p:sldId id="268" r:id="rId11"/>
   </p:sldIdLst>
   <p:sldSz cx="9144000" cy="5143500" type="screen16x9"/>
   <p:notesSz cx="5143500" cy="9144000"/>
@@ -328,6 +330,114 @@
 </p:notes>
 </file>
 
+<file path=ppt/notesSlides/notesSlide10.xml><?xml version="1.0" encoding="utf-8"?>
+<p:notes xmlns:a="http://schemas.openxmlformats.org/drawingml/2006/main" xmlns:r="http://schemas.openxmlformats.org/officeDocument/2006/relationships" xmlns:p="http://schemas.openxmlformats.org/presentationml/2006/main">
+  <p:cSld>
+    <p:spTree>
+      <p:nvGrpSpPr>
+        <p:cNvPr id="1" name="">
+          <a:extLst>
+            <a:ext uri="{FF2B5EF4-FFF2-40B4-BE49-F238E27FC236}">
+              <a16:creationId xmlns:a16="http://schemas.microsoft.com/office/drawing/2014/main" id="{6CF2D5FC-C4D3-91E4-E8EE-D351F3F33AB0}"/>
+            </a:ext>
+          </a:extLst>
+        </p:cNvPr>
+        <p:cNvGrpSpPr/>
+        <p:nvPr/>
+      </p:nvGrpSpPr>
+      <p:grpSpPr>
+        <a:xfrm>
+          <a:off x="0" y="0"/>
+          <a:ext cx="0" cy="0"/>
+          <a:chOff x="0" y="0"/>
+          <a:chExt cx="0" cy="0"/>
+        </a:xfrm>
+      </p:grpSpPr>
+      <p:sp>
+        <p:nvSpPr>
+          <p:cNvPr id="2" name="Slide Image Placeholder 1">
+            <a:extLst>
+              <a:ext uri="{FF2B5EF4-FFF2-40B4-BE49-F238E27FC236}">
+                <a16:creationId xmlns:a16="http://schemas.microsoft.com/office/drawing/2014/main" id="{4D6C5432-54F3-B97C-9955-125662535E86}"/>
+              </a:ext>
+            </a:extLst>
+          </p:cNvPr>
+          <p:cNvSpPr>
+            <a:spLocks noGrp="1" noRot="1" noChangeAspect="1"/>
+          </p:cNvSpPr>
+          <p:nvPr>
+            <p:ph type="sldImg"/>
+          </p:nvPr>
+        </p:nvSpPr>
+        <p:spPr/>
+      </p:sp>
+      <p:sp>
+        <p:nvSpPr>
+          <p:cNvPr id="3" name="Notes Placeholder 2">
+            <a:extLst>
+              <a:ext uri="{FF2B5EF4-FFF2-40B4-BE49-F238E27FC236}">
+                <a16:creationId xmlns:a16="http://schemas.microsoft.com/office/drawing/2014/main" id="{3B3FE8A5-795A-6769-4533-AD9BAF69553F}"/>
+              </a:ext>
+            </a:extLst>
+          </p:cNvPr>
+          <p:cNvSpPr>
+            <a:spLocks noGrp="1"/>
+          </p:cNvSpPr>
+          <p:nvPr>
+            <p:ph type="body" idx="1"/>
+          </p:nvPr>
+        </p:nvSpPr>
+        <p:spPr/>
+        <p:txBody>
+          <a:bodyPr/>
+          <a:lstStyle/>
+          <a:p>
+            <a:endParaRPr lang="en-US" dirty="0"/>
+          </a:p>
+        </p:txBody>
+      </p:sp>
+      <p:sp>
+        <p:nvSpPr>
+          <p:cNvPr id="4" name="Slide Number Placeholder 3">
+            <a:extLst>
+              <a:ext uri="{FF2B5EF4-FFF2-40B4-BE49-F238E27FC236}">
+                <a16:creationId xmlns:a16="http://schemas.microsoft.com/office/drawing/2014/main" id="{926CE4DD-6BC6-CEC5-9C34-75012115B580}"/>
+              </a:ext>
+            </a:extLst>
+          </p:cNvPr>
+          <p:cNvSpPr>
+            <a:spLocks noGrp="1"/>
+          </p:cNvSpPr>
+          <p:nvPr>
+            <p:ph type="sldNum" sz="quarter" idx="10"/>
+          </p:nvPr>
+        </p:nvSpPr>
+        <p:spPr/>
+        <p:txBody>
+          <a:bodyPr/>
+          <a:lstStyle/>
+          <a:p>
+            <a:fld id="{F7021451-1387-4CA6-816F-3879F97B5CBC}" type="slidenum">
+              <a:rPr lang="en-US"/>
+              <a:t>10</a:t>
+            </a:fld>
+            <a:endParaRPr lang="en-US"/>
+          </a:p>
+        </p:txBody>
+      </p:sp>
+    </p:spTree>
+    <p:extLst>
+      <p:ext uri="{BB962C8B-B14F-4D97-AF65-F5344CB8AC3E}">
+        <p14:creationId xmlns:p14="http://schemas.microsoft.com/office/powerpoint/2010/main" val="3850579304"/>
+      </p:ext>
+    </p:extLst>
+  </p:cSld>
+  <p:clrMapOvr>
+    <a:masterClrMapping/>
+  </p:clrMapOvr>
+</p:notes>
+</file>
+
 <file path=ppt/notesSlides/notesSlide2.xml><?xml version="1.0" encoding="utf-8"?>
 <p:notes xmlns:a="http://schemas.openxmlformats.org/drawingml/2006/main" xmlns:r="http://schemas.openxmlformats.org/officeDocument/2006/relationships" xmlns:p="http://schemas.openxmlformats.org/presentationml/2006/main">
   <p:cSld>
@@ -624,6 +734,632 @@
           <a:bodyPr/>
           <a:lstStyle/>
           <a:p>
+            <a:r>
+              <a:rPr lang="en-US" sz="1200" b="1" i="0" kern="1200" dirty="0">
+                <a:solidFill>
+                  <a:schemeClr val="tx1"/>
+                </a:solidFill>
+                <a:effectLst/>
+                <a:latin typeface="+mn-lt"/>
+                <a:ea typeface="+mn-ea"/>
+                <a:cs typeface="+mn-cs"/>
+              </a:rPr>
+              <a:t>1. Load history</a:t>
+            </a:r>
+            <a:r>
+              <a:rPr lang="en-US" sz="1200" b="0" i="0" kern="1200" dirty="0">
+                <a:solidFill>
+                  <a:schemeClr val="tx1"/>
+                </a:solidFill>
+                <a:effectLst/>
+                <a:latin typeface="+mn-lt"/>
+                <a:ea typeface="+mn-ea"/>
+                <a:cs typeface="+mn-cs"/>
+              </a:rPr>
+              <a:t> Query all </a:t>
+            </a:r>
+            <a:r>
+              <a:rPr lang="en-US" sz="1200" b="0" i="0" kern="1200" dirty="0" err="1">
+                <a:solidFill>
+                  <a:schemeClr val="tx1"/>
+                </a:solidFill>
+                <a:effectLst/>
+                <a:latin typeface="+mn-lt"/>
+                <a:ea typeface="+mn-ea"/>
+                <a:cs typeface="+mn-cs"/>
+              </a:rPr>
+              <a:t>DistributedTrainingHistory</a:t>
+            </a:r>
+            <a:r>
+              <a:rPr lang="en-US" sz="1200" b="0" i="0" kern="1200" dirty="0">
+                <a:solidFill>
+                  <a:schemeClr val="tx1"/>
+                </a:solidFill>
+                <a:effectLst/>
+                <a:latin typeface="+mn-lt"/>
+                <a:ea typeface="+mn-ea"/>
+                <a:cs typeface="+mn-cs"/>
+              </a:rPr>
+              <a:t> CRs matching this config hash. Group entries by node count and average throughput at each — if no history exists, fall back to a default calibration topology to collect the first data point.</a:t>
+            </a:r>
+          </a:p>
+          <a:p>
+            <a:r>
+              <a:rPr lang="en-US" sz="1200" b="1" i="0" kern="1200" dirty="0">
+                <a:solidFill>
+                  <a:schemeClr val="tx1"/>
+                </a:solidFill>
+                <a:effectLst/>
+                <a:latin typeface="+mn-lt"/>
+                <a:ea typeface="+mn-ea"/>
+                <a:cs typeface="+mn-cs"/>
+              </a:rPr>
+              <a:t>2. Derive base rate</a:t>
+            </a:r>
+            <a:r>
+              <a:rPr lang="en-US" sz="1200" b="0" i="0" kern="1200" dirty="0">
+                <a:solidFill>
+                  <a:schemeClr val="tx1"/>
+                </a:solidFill>
+                <a:effectLst/>
+                <a:latin typeface="+mn-lt"/>
+                <a:ea typeface="+mn-ea"/>
+                <a:cs typeface="+mn-cs"/>
+              </a:rPr>
+              <a:t> From the smallest observed node count </a:t>
+            </a:r>
+            <a:r>
+              <a:rPr lang="en-US" sz="1200" b="0" i="0" kern="1200" dirty="0" err="1">
+                <a:solidFill>
+                  <a:schemeClr val="tx1"/>
+                </a:solidFill>
+                <a:effectLst/>
+                <a:latin typeface="+mn-lt"/>
+                <a:ea typeface="+mn-ea"/>
+                <a:cs typeface="+mn-cs"/>
+              </a:rPr>
+              <a:t>n_min</a:t>
+            </a:r>
+            <a:r>
+              <a:rPr lang="en-US" sz="1200" b="0" i="0" kern="1200" dirty="0">
+                <a:solidFill>
+                  <a:schemeClr val="tx1"/>
+                </a:solidFill>
+                <a:effectLst/>
+                <a:latin typeface="+mn-lt"/>
+                <a:ea typeface="+mn-ea"/>
+                <a:cs typeface="+mn-cs"/>
+              </a:rPr>
+              <a:t>, compute single-node throughput </a:t>
+            </a:r>
+            <a:r>
+              <a:rPr lang="en-US" sz="1200" b="1" i="0" kern="1200" dirty="0">
+                <a:solidFill>
+                  <a:schemeClr val="tx1"/>
+                </a:solidFill>
+                <a:effectLst/>
+                <a:latin typeface="+mn-lt"/>
+                <a:ea typeface="+mn-ea"/>
+                <a:cs typeface="+mn-cs"/>
+              </a:rPr>
+              <a:t>P₀ = </a:t>
+            </a:r>
+            <a:r>
+              <a:rPr lang="en-US" sz="1200" b="1" i="0" kern="1200" dirty="0" err="1">
+                <a:solidFill>
+                  <a:schemeClr val="tx1"/>
+                </a:solidFill>
+                <a:effectLst/>
+                <a:latin typeface="+mn-lt"/>
+                <a:ea typeface="+mn-ea"/>
+                <a:cs typeface="+mn-cs"/>
+              </a:rPr>
+              <a:t>P_min</a:t>
+            </a:r>
+            <a:r>
+              <a:rPr lang="en-US" sz="1200" b="1" i="0" kern="1200" dirty="0">
+                <a:solidFill>
+                  <a:schemeClr val="tx1"/>
+                </a:solidFill>
+                <a:effectLst/>
+                <a:latin typeface="+mn-lt"/>
+                <a:ea typeface="+mn-ea"/>
+                <a:cs typeface="+mn-cs"/>
+              </a:rPr>
+              <a:t> / </a:t>
+            </a:r>
+            <a:r>
+              <a:rPr lang="en-US" sz="1200" b="1" i="0" kern="1200" dirty="0" err="1">
+                <a:solidFill>
+                  <a:schemeClr val="tx1"/>
+                </a:solidFill>
+                <a:effectLst/>
+                <a:latin typeface="+mn-lt"/>
+                <a:ea typeface="+mn-ea"/>
+                <a:cs typeface="+mn-cs"/>
+              </a:rPr>
+              <a:t>n_min</a:t>
+            </a:r>
+            <a:r>
+              <a:rPr lang="en-US" sz="1200" b="0" i="0" kern="1200" dirty="0">
+                <a:solidFill>
+                  <a:schemeClr val="tx1"/>
+                </a:solidFill>
+                <a:effectLst/>
+                <a:latin typeface="+mn-lt"/>
+                <a:ea typeface="+mn-ea"/>
+                <a:cs typeface="+mn-cs"/>
+              </a:rPr>
+              <a:t>. Also extract total work volume </a:t>
+            </a:r>
+            <a:r>
+              <a:rPr lang="en-US" sz="1200" b="1" i="0" kern="1200" dirty="0">
+                <a:solidFill>
+                  <a:schemeClr val="tx1"/>
+                </a:solidFill>
+                <a:effectLst/>
+                <a:latin typeface="+mn-lt"/>
+                <a:ea typeface="+mn-ea"/>
+                <a:cs typeface="+mn-cs"/>
+              </a:rPr>
+              <a:t>W</a:t>
+            </a:r>
+            <a:r>
+              <a:rPr lang="en-US" sz="1200" b="0" i="0" kern="1200" dirty="0">
+                <a:solidFill>
+                  <a:schemeClr val="tx1"/>
+                </a:solidFill>
+                <a:effectLst/>
+                <a:latin typeface="+mn-lt"/>
+                <a:ea typeface="+mn-ea"/>
+                <a:cs typeface="+mn-cs"/>
+              </a:rPr>
+              <a:t> and average provisioning time </a:t>
+            </a:r>
+            <a:r>
+              <a:rPr lang="en-US" sz="1200" b="1" i="0" kern="1200" dirty="0" err="1">
+                <a:solidFill>
+                  <a:schemeClr val="tx1"/>
+                </a:solidFill>
+                <a:effectLst/>
+                <a:latin typeface="+mn-lt"/>
+                <a:ea typeface="+mn-ea"/>
+                <a:cs typeface="+mn-cs"/>
+              </a:rPr>
+              <a:t>t_prov</a:t>
+            </a:r>
+            <a:r>
+              <a:rPr lang="en-US" sz="1200" b="0" i="0" kern="1200" dirty="0">
+                <a:solidFill>
+                  <a:schemeClr val="tx1"/>
+                </a:solidFill>
+                <a:effectLst/>
+                <a:latin typeface="+mn-lt"/>
+                <a:ea typeface="+mn-ea"/>
+                <a:cs typeface="+mn-cs"/>
+              </a:rPr>
+              <a:t> — both feed directly into the time and cost predictions.</a:t>
+            </a:r>
+          </a:p>
+          <a:p>
+            <a:r>
+              <a:rPr lang="en-US" sz="1200" b="1" i="0" kern="1200" dirty="0">
+                <a:solidFill>
+                  <a:schemeClr val="tx1"/>
+                </a:solidFill>
+                <a:effectLst/>
+                <a:latin typeface="+mn-lt"/>
+                <a:ea typeface="+mn-ea"/>
+                <a:cs typeface="+mn-cs"/>
+              </a:rPr>
+              <a:t>3. Fit α (scaling overhead)</a:t>
+            </a:r>
+            <a:r>
+              <a:rPr lang="en-US" sz="1200" b="0" i="0" kern="1200" dirty="0">
+                <a:solidFill>
+                  <a:schemeClr val="tx1"/>
+                </a:solidFill>
+                <a:effectLst/>
+                <a:latin typeface="+mn-lt"/>
+                <a:ea typeface="+mn-ea"/>
+                <a:cs typeface="+mn-cs"/>
+              </a:rPr>
+              <a:t> Model throughput as </a:t>
+            </a:r>
+            <a:r>
+              <a:rPr lang="en-US" sz="1200" b="1" i="0" kern="1200" dirty="0">
+                <a:solidFill>
+                  <a:schemeClr val="tx1"/>
+                </a:solidFill>
+                <a:effectLst/>
+                <a:latin typeface="+mn-lt"/>
+                <a:ea typeface="+mn-ea"/>
+                <a:cs typeface="+mn-cs"/>
+              </a:rPr>
+              <a:t>P(n) = P₀ · n · η(n)</a:t>
+            </a:r>
+            <a:r>
+              <a:rPr lang="en-US" sz="1200" b="0" i="0" kern="1200" dirty="0">
+                <a:solidFill>
+                  <a:schemeClr val="tx1"/>
+                </a:solidFill>
+                <a:effectLst/>
+                <a:latin typeface="+mn-lt"/>
+                <a:ea typeface="+mn-ea"/>
+                <a:cs typeface="+mn-cs"/>
+              </a:rPr>
+              <a:t>, where η(n) = 1 / (1 + α(n−1)) captures efficiency loss from coordination overhead.</a:t>
+            </a:r>
+          </a:p>
+          <a:p>
+            <a:r>
+              <a:rPr lang="en-US" sz="1200" b="1" i="0" kern="1200" dirty="0">
+                <a:solidFill>
+                  <a:schemeClr val="tx1"/>
+                </a:solidFill>
+                <a:effectLst/>
+                <a:latin typeface="+mn-lt"/>
+                <a:ea typeface="+mn-ea"/>
+                <a:cs typeface="+mn-cs"/>
+              </a:rPr>
+              <a:t>1 distinct node count</a:t>
+            </a:r>
+            <a:r>
+              <a:rPr lang="en-US" sz="1200" b="0" i="0" kern="1200" dirty="0">
+                <a:solidFill>
+                  <a:schemeClr val="tx1"/>
+                </a:solidFill>
+                <a:effectLst/>
+                <a:latin typeface="+mn-lt"/>
+                <a:ea typeface="+mn-ea"/>
+                <a:cs typeface="+mn-cs"/>
+              </a:rPr>
+              <a:t> → α = 0, linear scaling assumed</a:t>
+            </a:r>
+          </a:p>
+          <a:p>
+            <a:r>
+              <a:rPr lang="en-US" sz="1200" b="1" i="0" kern="1200" dirty="0">
+                <a:solidFill>
+                  <a:schemeClr val="tx1"/>
+                </a:solidFill>
+                <a:effectLst/>
+                <a:latin typeface="+mn-lt"/>
+                <a:ea typeface="+mn-ea"/>
+                <a:cs typeface="+mn-cs"/>
+              </a:rPr>
+              <a:t>2 distinct node counts</a:t>
+            </a:r>
+            <a:r>
+              <a:rPr lang="en-US" sz="1200" b="0" i="0" kern="1200" dirty="0">
+                <a:solidFill>
+                  <a:schemeClr val="tx1"/>
+                </a:solidFill>
+                <a:effectLst/>
+                <a:latin typeface="+mn-lt"/>
+                <a:ea typeface="+mn-ea"/>
+                <a:cs typeface="+mn-cs"/>
+              </a:rPr>
+              <a:t> → closed-form solution: α = (1 − </a:t>
+            </a:r>
+            <a:r>
+              <a:rPr lang="en-US" sz="1200" b="0" i="0" kern="1200" dirty="0" err="1">
+                <a:solidFill>
+                  <a:schemeClr val="tx1"/>
+                </a:solidFill>
+                <a:effectLst/>
+                <a:latin typeface="+mn-lt"/>
+                <a:ea typeface="+mn-ea"/>
+                <a:cs typeface="+mn-cs"/>
+              </a:rPr>
+              <a:t>η_obs</a:t>
+            </a:r>
+            <a:r>
+              <a:rPr lang="en-US" sz="1200" b="0" i="0" kern="1200" dirty="0">
+                <a:solidFill>
+                  <a:schemeClr val="tx1"/>
+                </a:solidFill>
+                <a:effectLst/>
+                <a:latin typeface="+mn-lt"/>
+                <a:ea typeface="+mn-ea"/>
+                <a:cs typeface="+mn-cs"/>
+              </a:rPr>
+              <a:t>) / (</a:t>
+            </a:r>
+            <a:r>
+              <a:rPr lang="en-US" sz="1200" b="0" i="0" kern="1200" dirty="0" err="1">
+                <a:solidFill>
+                  <a:schemeClr val="tx1"/>
+                </a:solidFill>
+                <a:effectLst/>
+                <a:latin typeface="+mn-lt"/>
+                <a:ea typeface="+mn-ea"/>
+                <a:cs typeface="+mn-cs"/>
+              </a:rPr>
+              <a:t>η_obs</a:t>
+            </a:r>
+            <a:r>
+              <a:rPr lang="en-US" sz="1200" b="0" i="0" kern="1200" dirty="0">
+                <a:solidFill>
+                  <a:schemeClr val="tx1"/>
+                </a:solidFill>
+                <a:effectLst/>
+                <a:latin typeface="+mn-lt"/>
+                <a:ea typeface="+mn-ea"/>
+                <a:cs typeface="+mn-cs"/>
+              </a:rPr>
+              <a:t> · (n − 1))</a:t>
+            </a:r>
+          </a:p>
+          <a:p>
+            <a:r>
+              <a:rPr lang="en-US" sz="1200" b="1" i="0" kern="1200" dirty="0">
+                <a:solidFill>
+                  <a:schemeClr val="tx1"/>
+                </a:solidFill>
+                <a:effectLst/>
+                <a:latin typeface="+mn-lt"/>
+                <a:ea typeface="+mn-ea"/>
+                <a:cs typeface="+mn-cs"/>
+              </a:rPr>
+              <a:t>3+ distinct node counts</a:t>
+            </a:r>
+            <a:r>
+              <a:rPr lang="en-US" sz="1200" b="0" i="0" kern="1200" dirty="0">
+                <a:solidFill>
+                  <a:schemeClr val="tx1"/>
+                </a:solidFill>
+                <a:effectLst/>
+                <a:latin typeface="+mn-lt"/>
+                <a:ea typeface="+mn-ea"/>
+                <a:cs typeface="+mn-cs"/>
+              </a:rPr>
+              <a:t> → golden-section search </a:t>
+            </a:r>
+            <a:r>
+              <a:rPr lang="en-US" sz="1200" b="0" i="0" kern="1200" dirty="0" err="1">
+                <a:solidFill>
+                  <a:schemeClr val="tx1"/>
+                </a:solidFill>
+                <a:effectLst/>
+                <a:latin typeface="+mn-lt"/>
+                <a:ea typeface="+mn-ea"/>
+                <a:cs typeface="+mn-cs"/>
+              </a:rPr>
+              <a:t>minimising</a:t>
+            </a:r>
+            <a:r>
+              <a:rPr lang="en-US" sz="1200" b="0" i="0" kern="1200" dirty="0">
+                <a:solidFill>
+                  <a:schemeClr val="tx1"/>
+                </a:solidFill>
+                <a:effectLst/>
+                <a:latin typeface="+mn-lt"/>
+                <a:ea typeface="+mn-ea"/>
+                <a:cs typeface="+mn-cs"/>
+              </a:rPr>
+              <a:t> sum of squared residuals across all observations</a:t>
+            </a:r>
+          </a:p>
+          <a:p>
+            <a:r>
+              <a:rPr lang="en-US" sz="1200" b="1" i="0" kern="1200" dirty="0">
+                <a:solidFill>
+                  <a:schemeClr val="tx1"/>
+                </a:solidFill>
+                <a:effectLst/>
+                <a:latin typeface="+mn-lt"/>
+                <a:ea typeface="+mn-ea"/>
+                <a:cs typeface="+mn-cs"/>
+              </a:rPr>
+              <a:t>4. Select optimal node count</a:t>
+            </a:r>
+            <a:r>
+              <a:rPr lang="en-US" sz="1200" b="0" i="0" kern="1200" dirty="0">
+                <a:solidFill>
+                  <a:schemeClr val="tx1"/>
+                </a:solidFill>
+                <a:effectLst/>
+                <a:latin typeface="+mn-lt"/>
+                <a:ea typeface="+mn-ea"/>
+                <a:cs typeface="+mn-cs"/>
+              </a:rPr>
+              <a:t> Predict </a:t>
+            </a:r>
+            <a:r>
+              <a:rPr lang="en-US" sz="1200" b="1" i="0" kern="1200" dirty="0">
+                <a:solidFill>
+                  <a:schemeClr val="tx1"/>
+                </a:solidFill>
+                <a:effectLst/>
+                <a:latin typeface="+mn-lt"/>
+                <a:ea typeface="+mn-ea"/>
+                <a:cs typeface="+mn-cs"/>
+              </a:rPr>
+              <a:t>T(n) = W / P(n)</a:t>
+            </a:r>
+            <a:r>
+              <a:rPr lang="en-US" sz="1200" b="0" i="0" kern="1200" dirty="0">
+                <a:solidFill>
+                  <a:schemeClr val="tx1"/>
+                </a:solidFill>
+                <a:effectLst/>
+                <a:latin typeface="+mn-lt"/>
+                <a:ea typeface="+mn-ea"/>
+                <a:cs typeface="+mn-cs"/>
+              </a:rPr>
+              <a:t> and </a:t>
+            </a:r>
+            <a:r>
+              <a:rPr lang="en-US" sz="1200" b="1" i="0" kern="1200" dirty="0">
+                <a:solidFill>
+                  <a:schemeClr val="tx1"/>
+                </a:solidFill>
+                <a:effectLst/>
+                <a:latin typeface="+mn-lt"/>
+                <a:ea typeface="+mn-ea"/>
+                <a:cs typeface="+mn-cs"/>
+              </a:rPr>
+              <a:t>Cost(n) = n · rate · (T(n) + </a:t>
+            </a:r>
+            <a:r>
+              <a:rPr lang="en-US" sz="1200" b="1" i="0" kern="1200" dirty="0" err="1">
+                <a:solidFill>
+                  <a:schemeClr val="tx1"/>
+                </a:solidFill>
+                <a:effectLst/>
+                <a:latin typeface="+mn-lt"/>
+                <a:ea typeface="+mn-ea"/>
+                <a:cs typeface="+mn-cs"/>
+              </a:rPr>
+              <a:t>t_prov</a:t>
+            </a:r>
+            <a:r>
+              <a:rPr lang="en-US" sz="1200" b="1" i="0" kern="1200" dirty="0">
+                <a:solidFill>
+                  <a:schemeClr val="tx1"/>
+                </a:solidFill>
+                <a:effectLst/>
+                <a:latin typeface="+mn-lt"/>
+                <a:ea typeface="+mn-ea"/>
+                <a:cs typeface="+mn-cs"/>
+              </a:rPr>
+              <a:t>)</a:t>
+            </a:r>
+            <a:r>
+              <a:rPr lang="en-US" sz="1200" b="0" i="0" kern="1200" dirty="0">
+                <a:solidFill>
+                  <a:schemeClr val="tx1"/>
+                </a:solidFill>
+                <a:effectLst/>
+                <a:latin typeface="+mn-lt"/>
+                <a:ea typeface="+mn-ea"/>
+                <a:cs typeface="+mn-cs"/>
+              </a:rPr>
+              <a:t> for each candidate n. Then:</a:t>
+            </a:r>
+          </a:p>
+          <a:p>
+            <a:r>
+              <a:rPr lang="en-US" sz="1200" b="0" i="1" kern="1200" dirty="0">
+                <a:solidFill>
+                  <a:schemeClr val="tx1"/>
+                </a:solidFill>
+                <a:effectLst/>
+                <a:latin typeface="+mn-lt"/>
+                <a:ea typeface="+mn-ea"/>
+                <a:cs typeface="+mn-cs"/>
+              </a:rPr>
+              <a:t>Time objective only</a:t>
+            </a:r>
+            <a:r>
+              <a:rPr lang="en-US" sz="1200" b="0" i="0" kern="1200" dirty="0">
+                <a:solidFill>
+                  <a:schemeClr val="tx1"/>
+                </a:solidFill>
+                <a:effectLst/>
+                <a:latin typeface="+mn-lt"/>
+                <a:ea typeface="+mn-ea"/>
+                <a:cs typeface="+mn-cs"/>
+              </a:rPr>
+              <a:t> → binary search for the smallest n where T(n) ≤ </a:t>
+            </a:r>
+            <a:r>
+              <a:rPr lang="en-US" sz="1200" b="0" i="0" kern="1200" dirty="0" err="1">
+                <a:solidFill>
+                  <a:schemeClr val="tx1"/>
+                </a:solidFill>
+                <a:effectLst/>
+                <a:latin typeface="+mn-lt"/>
+                <a:ea typeface="+mn-ea"/>
+                <a:cs typeface="+mn-cs"/>
+              </a:rPr>
+              <a:t>targetTime</a:t>
+            </a:r>
+            <a:endParaRPr lang="en-US" sz="1200" b="0" i="0" kern="1200" dirty="0">
+              <a:solidFill>
+                <a:schemeClr val="tx1"/>
+              </a:solidFill>
+              <a:effectLst/>
+              <a:latin typeface="+mn-lt"/>
+              <a:ea typeface="+mn-ea"/>
+              <a:cs typeface="+mn-cs"/>
+            </a:endParaRPr>
+          </a:p>
+          <a:p>
+            <a:r>
+              <a:rPr lang="en-US" sz="1200" b="0" i="1" kern="1200" dirty="0">
+                <a:solidFill>
+                  <a:schemeClr val="tx1"/>
+                </a:solidFill>
+                <a:effectLst/>
+                <a:latin typeface="+mn-lt"/>
+                <a:ea typeface="+mn-ea"/>
+                <a:cs typeface="+mn-cs"/>
+              </a:rPr>
+              <a:t>Cost objective only</a:t>
+            </a:r>
+            <a:r>
+              <a:rPr lang="en-US" sz="1200" b="0" i="0" kern="1200" dirty="0">
+                <a:solidFill>
+                  <a:schemeClr val="tx1"/>
+                </a:solidFill>
+                <a:effectLst/>
+                <a:latin typeface="+mn-lt"/>
+                <a:ea typeface="+mn-ea"/>
+                <a:cs typeface="+mn-cs"/>
+              </a:rPr>
+              <a:t> → binary search for the largest n where Cost(n) ≤ </a:t>
+            </a:r>
+            <a:r>
+              <a:rPr lang="en-US" sz="1200" b="0" i="0" kern="1200" dirty="0" err="1">
+                <a:solidFill>
+                  <a:schemeClr val="tx1"/>
+                </a:solidFill>
+                <a:effectLst/>
+                <a:latin typeface="+mn-lt"/>
+                <a:ea typeface="+mn-ea"/>
+                <a:cs typeface="+mn-cs"/>
+              </a:rPr>
+              <a:t>maxCost</a:t>
+            </a:r>
+            <a:endParaRPr lang="en-US" sz="1200" b="0" i="0" kern="1200" dirty="0">
+              <a:solidFill>
+                <a:schemeClr val="tx1"/>
+              </a:solidFill>
+              <a:effectLst/>
+              <a:latin typeface="+mn-lt"/>
+              <a:ea typeface="+mn-ea"/>
+              <a:cs typeface="+mn-cs"/>
+            </a:endParaRPr>
+          </a:p>
+          <a:p>
+            <a:r>
+              <a:rPr lang="en-US" sz="1200" b="0" i="1" kern="1200" dirty="0">
+                <a:solidFill>
+                  <a:schemeClr val="tx1"/>
+                </a:solidFill>
+                <a:effectLst/>
+                <a:latin typeface="+mn-lt"/>
+                <a:ea typeface="+mn-ea"/>
+                <a:cs typeface="+mn-cs"/>
+              </a:rPr>
+              <a:t>Both</a:t>
+            </a:r>
+            <a:r>
+              <a:rPr lang="en-US" sz="1200" b="0" i="0" kern="1200" dirty="0">
+                <a:solidFill>
+                  <a:schemeClr val="tx1"/>
+                </a:solidFill>
+                <a:effectLst/>
+                <a:latin typeface="+mn-lt"/>
+                <a:ea typeface="+mn-ea"/>
+                <a:cs typeface="+mn-cs"/>
+              </a:rPr>
+              <a:t> → find n satisfying time first, then verify cost; back off toward fewer nodes until both constraints are met</a:t>
+            </a:r>
+          </a:p>
+          <a:p>
             <a:endParaRPr lang="en-US" dirty="0"/>
           </a:p>
         </p:txBody>
@@ -898,6 +1634,90 @@
             <a:fld id="{F7021451-1387-4CA6-816F-3879F97B5CBC}" type="slidenum">
               <a:rPr lang="en-US"/>
               <a:t>8</a:t>
+            </a:fld>
+            <a:endParaRPr lang="en-US"/>
+          </a:p>
+        </p:txBody>
+      </p:sp>
+    </p:spTree>
+    <p:extLst>
+      <p:ext uri="{BB962C8B-B14F-4D97-AF65-F5344CB8AC3E}">
+        <p14:creationId xmlns:p14="http://schemas.microsoft.com/office/powerpoint/2010/main" val="1024086991"/>
+      </p:ext>
+    </p:extLst>
+  </p:cSld>
+  <p:clrMapOvr>
+    <a:masterClrMapping/>
+  </p:clrMapOvr>
+</p:notes>
+</file>
+
+<file path=ppt/notesSlides/notesSlide9.xml><?xml version="1.0" encoding="utf-8"?>
+<p:notes xmlns:a="http://schemas.openxmlformats.org/drawingml/2006/main" xmlns:r="http://schemas.openxmlformats.org/officeDocument/2006/relationships" xmlns:p="http://schemas.openxmlformats.org/presentationml/2006/main">
+  <p:cSld>
+    <p:spTree>
+      <p:nvGrpSpPr>
+        <p:cNvPr id="1" name=""/>
+        <p:cNvGrpSpPr/>
+        <p:nvPr/>
+      </p:nvGrpSpPr>
+      <p:grpSpPr>
+        <a:xfrm>
+          <a:off x="0" y="0"/>
+          <a:ext cx="0" cy="0"/>
+          <a:chOff x="0" y="0"/>
+          <a:chExt cx="0" cy="0"/>
+        </a:xfrm>
+      </p:grpSpPr>
+      <p:sp>
+        <p:nvSpPr>
+          <p:cNvPr id="2" name="Slide Image Placeholder 1"/>
+          <p:cNvSpPr>
+            <a:spLocks noGrp="1" noRot="1" noChangeAspect="1"/>
+          </p:cNvSpPr>
+          <p:nvPr>
+            <p:ph type="sldImg"/>
+          </p:nvPr>
+        </p:nvSpPr>
+        <p:spPr/>
+      </p:sp>
+      <p:sp>
+        <p:nvSpPr>
+          <p:cNvPr id="3" name="Notes Placeholder 2"/>
+          <p:cNvSpPr>
+            <a:spLocks noGrp="1"/>
+          </p:cNvSpPr>
+          <p:nvPr>
+            <p:ph type="body" idx="1"/>
+          </p:nvPr>
+        </p:nvSpPr>
+        <p:spPr/>
+        <p:txBody>
+          <a:bodyPr/>
+          <a:lstStyle/>
+          <a:p>
+            <a:endParaRPr lang="en-US" dirty="0"/>
+          </a:p>
+        </p:txBody>
+      </p:sp>
+      <p:sp>
+        <p:nvSpPr>
+          <p:cNvPr id="4" name="Slide Number Placeholder 3"/>
+          <p:cNvSpPr>
+            <a:spLocks noGrp="1"/>
+          </p:cNvSpPr>
+          <p:nvPr>
+            <p:ph type="sldNum" sz="quarter" idx="10"/>
+          </p:nvPr>
+        </p:nvSpPr>
+        <p:spPr/>
+        <p:txBody>
+          <a:bodyPr/>
+          <a:lstStyle/>
+          <a:p>
+            <a:fld id="{F7021451-1387-4CA6-816F-3879F97B5CBC}" type="slidenum">
+              <a:rPr lang="en-US"/>
+              <a:t>9</a:t>
             </a:fld>
             <a:endParaRPr lang="en-US"/>
           </a:p>
@@ -1571,6 +2391,1506 @@
 </p:sld>
 </file>
 
+<file path=ppt/slides/slide10.xml><?xml version="1.0" encoding="utf-8"?>
+<p:sld xmlns:a="http://schemas.openxmlformats.org/drawingml/2006/main" xmlns:r="http://schemas.openxmlformats.org/officeDocument/2006/relationships" xmlns:p="http://schemas.openxmlformats.org/presentationml/2006/main">
+  <p:cSld>
+    <p:spTree>
+      <p:nvGrpSpPr>
+        <p:cNvPr id="1" name="">
+          <a:extLst>
+            <a:ext uri="{FF2B5EF4-FFF2-40B4-BE49-F238E27FC236}">
+              <a16:creationId xmlns:a16="http://schemas.microsoft.com/office/drawing/2014/main" id="{08D30D28-B791-DBE6-DBCD-843258F16C4B}"/>
+            </a:ext>
+          </a:extLst>
+        </p:cNvPr>
+        <p:cNvGrpSpPr/>
+        <p:nvPr/>
+      </p:nvGrpSpPr>
+      <p:grpSpPr>
+        <a:xfrm>
+          <a:off x="0" y="0"/>
+          <a:ext cx="0" cy="0"/>
+          <a:chOff x="0" y="0"/>
+          <a:chExt cx="0" cy="0"/>
+        </a:xfrm>
+      </p:grpSpPr>
+      <p:sp>
+        <p:nvSpPr>
+          <p:cNvPr id="2" name="Text 0">
+            <a:extLst>
+              <a:ext uri="{FF2B5EF4-FFF2-40B4-BE49-F238E27FC236}">
+                <a16:creationId xmlns:a16="http://schemas.microsoft.com/office/drawing/2014/main" id="{5AD93C63-A39D-B4AC-C441-5823227A03FF}"/>
+              </a:ext>
+            </a:extLst>
+          </p:cNvPr>
+          <p:cNvSpPr/>
+          <p:nvPr/>
+        </p:nvSpPr>
+        <p:spPr>
+          <a:xfrm>
+            <a:off x="502920" y="274320"/>
+            <a:ext cx="8138160" cy="640080"/>
+          </a:xfrm>
+          <a:prstGeom prst="rect">
+            <a:avLst/>
+          </a:prstGeom>
+          <a:noFill/>
+          <a:ln/>
+        </p:spPr>
+        <p:txBody>
+          <a:bodyPr wrap="square" lIns="0" tIns="0" rIns="0" bIns="0" rtlCol="0" anchor="ctr"/>
+          <a:lstStyle/>
+          <a:p>
+            <a:pPr marL="0" indent="0" algn="l">
+              <a:buNone/>
+            </a:pPr>
+            <a:r>
+              <a:rPr lang="en-US" sz="3200" b="1" dirty="0">
+                <a:solidFill>
+                  <a:srgbClr val="1E3A8A"/>
+                </a:solidFill>
+                <a:latin typeface="Calibri" pitchFamily="34" charset="0"/>
+                <a:ea typeface="Calibri" pitchFamily="34" charset="-122"/>
+                <a:cs typeface="Calibri" pitchFamily="34" charset="-120"/>
+              </a:rPr>
+              <a:t>How the Solver Works</a:t>
+            </a:r>
+            <a:endParaRPr lang="en-US" sz="3200" dirty="0"/>
+          </a:p>
+        </p:txBody>
+      </p:sp>
+      <p:sp>
+        <p:nvSpPr>
+          <p:cNvPr id="3" name="Shape 1">
+            <a:extLst>
+              <a:ext uri="{FF2B5EF4-FFF2-40B4-BE49-F238E27FC236}">
+                <a16:creationId xmlns:a16="http://schemas.microsoft.com/office/drawing/2014/main" id="{4962E801-2DFB-6C3C-03B5-901F1D492338}"/>
+              </a:ext>
+            </a:extLst>
+          </p:cNvPr>
+          <p:cNvSpPr/>
+          <p:nvPr/>
+        </p:nvSpPr>
+        <p:spPr>
+          <a:xfrm>
+            <a:off x="502920" y="932688"/>
+            <a:ext cx="8138160" cy="27432"/>
+          </a:xfrm>
+          <a:prstGeom prst="rect">
+            <a:avLst/>
+          </a:prstGeom>
+          <a:solidFill>
+            <a:srgbClr val="3B82F6"/>
+          </a:solidFill>
+          <a:ln w="12700">
+            <a:solidFill>
+              <a:srgbClr val="3B82F6"/>
+            </a:solidFill>
+            <a:prstDash val="solid"/>
+          </a:ln>
+        </p:spPr>
+        <p:txBody>
+          <a:bodyPr/>
+          <a:lstStyle/>
+          <a:p>
+            <a:endParaRPr lang="en-US"/>
+          </a:p>
+        </p:txBody>
+      </p:sp>
+      <p:sp>
+        <p:nvSpPr>
+          <p:cNvPr id="4" name="Shape 2">
+            <a:extLst>
+              <a:ext uri="{FF2B5EF4-FFF2-40B4-BE49-F238E27FC236}">
+                <a16:creationId xmlns:a16="http://schemas.microsoft.com/office/drawing/2014/main" id="{27FDD543-020B-A86E-A603-B2BA26EE54F8}"/>
+              </a:ext>
+            </a:extLst>
+          </p:cNvPr>
+          <p:cNvSpPr/>
+          <p:nvPr/>
+        </p:nvSpPr>
+        <p:spPr>
+          <a:xfrm>
+            <a:off x="320040" y="1051560"/>
+            <a:ext cx="8503920" cy="850392"/>
+          </a:xfrm>
+          <a:prstGeom prst="rect">
+            <a:avLst/>
+          </a:prstGeom>
+          <a:solidFill>
+            <a:srgbClr val="DBEAFE"/>
+          </a:solidFill>
+          <a:ln w="6350">
+            <a:solidFill>
+              <a:srgbClr val="3B82F6"/>
+            </a:solidFill>
+            <a:prstDash val="solid"/>
+          </a:ln>
+        </p:spPr>
+        <p:txBody>
+          <a:bodyPr/>
+          <a:lstStyle/>
+          <a:p>
+            <a:endParaRPr lang="en-US"/>
+          </a:p>
+        </p:txBody>
+      </p:sp>
+      <p:sp>
+        <p:nvSpPr>
+          <p:cNvPr id="5" name="Shape 3">
+            <a:extLst>
+              <a:ext uri="{FF2B5EF4-FFF2-40B4-BE49-F238E27FC236}">
+                <a16:creationId xmlns:a16="http://schemas.microsoft.com/office/drawing/2014/main" id="{D35CE5A0-E61B-AD0C-A71E-E50B6420CC35}"/>
+              </a:ext>
+            </a:extLst>
+          </p:cNvPr>
+          <p:cNvSpPr/>
+          <p:nvPr/>
+        </p:nvSpPr>
+        <p:spPr>
+          <a:xfrm>
+            <a:off x="320040" y="1051560"/>
+            <a:ext cx="502920" cy="850392"/>
+          </a:xfrm>
+          <a:prstGeom prst="rect">
+            <a:avLst/>
+          </a:prstGeom>
+          <a:solidFill>
+            <a:srgbClr val="1D4ED8"/>
+          </a:solidFill>
+          <a:ln w="12700">
+            <a:solidFill>
+              <a:srgbClr val="1D4ED8"/>
+            </a:solidFill>
+            <a:prstDash val="solid"/>
+          </a:ln>
+        </p:spPr>
+        <p:txBody>
+          <a:bodyPr/>
+          <a:lstStyle/>
+          <a:p>
+            <a:endParaRPr lang="en-US"/>
+          </a:p>
+        </p:txBody>
+      </p:sp>
+      <p:sp>
+        <p:nvSpPr>
+          <p:cNvPr id="6" name="Text 4">
+            <a:extLst>
+              <a:ext uri="{FF2B5EF4-FFF2-40B4-BE49-F238E27FC236}">
+                <a16:creationId xmlns:a16="http://schemas.microsoft.com/office/drawing/2014/main" id="{24B3055E-AA84-61A4-152B-37637B2A97D8}"/>
+              </a:ext>
+            </a:extLst>
+          </p:cNvPr>
+          <p:cNvSpPr/>
+          <p:nvPr/>
+        </p:nvSpPr>
+        <p:spPr>
+          <a:xfrm>
+            <a:off x="320040" y="1051560"/>
+            <a:ext cx="502920" cy="850392"/>
+          </a:xfrm>
+          <a:prstGeom prst="rect">
+            <a:avLst/>
+          </a:prstGeom>
+          <a:noFill/>
+          <a:ln/>
+        </p:spPr>
+        <p:txBody>
+          <a:bodyPr wrap="square" lIns="0" tIns="0" rIns="0" bIns="0" rtlCol="0" anchor="ctr"/>
+          <a:lstStyle/>
+          <a:p>
+            <a:pPr marL="0" indent="0" algn="ctr">
+              <a:buNone/>
+            </a:pPr>
+            <a:r>
+              <a:rPr lang="en-US" sz="1800" b="1" dirty="0">
+                <a:solidFill>
+                  <a:srgbClr val="FFFFFF"/>
+                </a:solidFill>
+                <a:latin typeface="Calibri" pitchFamily="34" charset="0"/>
+                <a:ea typeface="Calibri" pitchFamily="34" charset="-122"/>
+                <a:cs typeface="Calibri" pitchFamily="34" charset="-120"/>
+              </a:rPr>
+              <a:t>1</a:t>
+            </a:r>
+            <a:endParaRPr lang="en-US" sz="1800" dirty="0"/>
+          </a:p>
+        </p:txBody>
+      </p:sp>
+      <p:sp>
+        <p:nvSpPr>
+          <p:cNvPr id="7" name="Text 5">
+            <a:extLst>
+              <a:ext uri="{FF2B5EF4-FFF2-40B4-BE49-F238E27FC236}">
+                <a16:creationId xmlns:a16="http://schemas.microsoft.com/office/drawing/2014/main" id="{5C96E7CA-2049-11AA-D6FA-E85CC7C24CD5}"/>
+              </a:ext>
+            </a:extLst>
+          </p:cNvPr>
+          <p:cNvSpPr/>
+          <p:nvPr/>
+        </p:nvSpPr>
+        <p:spPr>
+          <a:xfrm>
+            <a:off x="914400" y="1106424"/>
+            <a:ext cx="2468880" cy="237744"/>
+          </a:xfrm>
+          <a:prstGeom prst="rect">
+            <a:avLst/>
+          </a:prstGeom>
+          <a:noFill/>
+          <a:ln/>
+        </p:spPr>
+        <p:txBody>
+          <a:bodyPr wrap="square" lIns="0" tIns="0" rIns="0" bIns="0" rtlCol="0" anchor="ctr"/>
+          <a:lstStyle/>
+          <a:p>
+            <a:pPr marL="0" indent="0" algn="l">
+              <a:buNone/>
+            </a:pPr>
+            <a:r>
+              <a:rPr lang="en-US" sz="1100" b="1" dirty="0">
+                <a:solidFill>
+                  <a:srgbClr val="1E3A8A"/>
+                </a:solidFill>
+                <a:latin typeface="Calibri" pitchFamily="34" charset="0"/>
+                <a:ea typeface="Calibri" pitchFamily="34" charset="-122"/>
+                <a:cs typeface="Calibri" pitchFamily="34" charset="-120"/>
+              </a:rPr>
+              <a:t>Read history</a:t>
+            </a:r>
+            <a:endParaRPr lang="en-US" sz="1100" dirty="0"/>
+          </a:p>
+        </p:txBody>
+      </p:sp>
+      <p:sp>
+        <p:nvSpPr>
+          <p:cNvPr id="8" name="Text 6">
+            <a:extLst>
+              <a:ext uri="{FF2B5EF4-FFF2-40B4-BE49-F238E27FC236}">
+                <a16:creationId xmlns:a16="http://schemas.microsoft.com/office/drawing/2014/main" id="{FCAAA716-4E1E-A7CD-D243-DB8CA81B568D}"/>
+              </a:ext>
+            </a:extLst>
+          </p:cNvPr>
+          <p:cNvSpPr/>
+          <p:nvPr/>
+        </p:nvSpPr>
+        <p:spPr>
+          <a:xfrm>
+            <a:off x="914400" y="1362456"/>
+            <a:ext cx="2286000" cy="530352"/>
+          </a:xfrm>
+          <a:prstGeom prst="rect">
+            <a:avLst/>
+          </a:prstGeom>
+          <a:noFill/>
+          <a:ln/>
+        </p:spPr>
+        <p:txBody>
+          <a:bodyPr wrap="square" lIns="0" tIns="0" rIns="0" bIns="0" rtlCol="0" anchor="t"/>
+          <a:lstStyle/>
+          <a:p>
+            <a:pPr marL="0" indent="0" algn="l">
+              <a:buNone/>
+            </a:pPr>
+            <a:r>
+              <a:rPr lang="en-US" sz="950" dirty="0">
+                <a:solidFill>
+                  <a:srgbClr val="0F172A"/>
+                </a:solidFill>
+                <a:latin typeface="Calibri" pitchFamily="34" charset="0"/>
+                <a:ea typeface="Calibri" pitchFamily="34" charset="-122"/>
+                <a:cs typeface="Calibri" pitchFamily="34" charset="-120"/>
+              </a:rPr>
+              <a:t>Load DistributedJobHistory entries for this workload (same config hash). Group by node count N, average throughput P_k per group.</a:t>
+            </a:r>
+            <a:endParaRPr lang="en-US" sz="950" dirty="0"/>
+          </a:p>
+        </p:txBody>
+      </p:sp>
+      <p:sp>
+        <p:nvSpPr>
+          <p:cNvPr id="9" name="Shape 7">
+            <a:extLst>
+              <a:ext uri="{FF2B5EF4-FFF2-40B4-BE49-F238E27FC236}">
+                <a16:creationId xmlns:a16="http://schemas.microsoft.com/office/drawing/2014/main" id="{71E8AB75-01E6-2730-1C78-146D1D18B83A}"/>
+              </a:ext>
+            </a:extLst>
+          </p:cNvPr>
+          <p:cNvSpPr/>
+          <p:nvPr/>
+        </p:nvSpPr>
+        <p:spPr>
+          <a:xfrm>
+            <a:off x="320040" y="1956816"/>
+            <a:ext cx="8503920" cy="850392"/>
+          </a:xfrm>
+          <a:prstGeom prst="rect">
+            <a:avLst/>
+          </a:prstGeom>
+          <a:solidFill>
+            <a:srgbClr val="DBEAFE"/>
+          </a:solidFill>
+          <a:ln w="6350">
+            <a:solidFill>
+              <a:srgbClr val="3B82F6"/>
+            </a:solidFill>
+            <a:prstDash val="solid"/>
+          </a:ln>
+        </p:spPr>
+        <p:txBody>
+          <a:bodyPr/>
+          <a:lstStyle/>
+          <a:p>
+            <a:endParaRPr lang="en-US"/>
+          </a:p>
+        </p:txBody>
+      </p:sp>
+      <p:sp>
+        <p:nvSpPr>
+          <p:cNvPr id="10" name="Shape 8">
+            <a:extLst>
+              <a:ext uri="{FF2B5EF4-FFF2-40B4-BE49-F238E27FC236}">
+                <a16:creationId xmlns:a16="http://schemas.microsoft.com/office/drawing/2014/main" id="{7843DB91-234D-C4F0-F767-8858B4E4EA86}"/>
+              </a:ext>
+            </a:extLst>
+          </p:cNvPr>
+          <p:cNvSpPr/>
+          <p:nvPr/>
+        </p:nvSpPr>
+        <p:spPr>
+          <a:xfrm>
+            <a:off x="320040" y="1956816"/>
+            <a:ext cx="502920" cy="850392"/>
+          </a:xfrm>
+          <a:prstGeom prst="rect">
+            <a:avLst/>
+          </a:prstGeom>
+          <a:solidFill>
+            <a:srgbClr val="1D4ED8"/>
+          </a:solidFill>
+          <a:ln w="12700">
+            <a:solidFill>
+              <a:srgbClr val="1D4ED8"/>
+            </a:solidFill>
+            <a:prstDash val="solid"/>
+          </a:ln>
+        </p:spPr>
+        <p:txBody>
+          <a:bodyPr/>
+          <a:lstStyle/>
+          <a:p>
+            <a:endParaRPr lang="en-US"/>
+          </a:p>
+        </p:txBody>
+      </p:sp>
+      <p:sp>
+        <p:nvSpPr>
+          <p:cNvPr id="11" name="Text 9">
+            <a:extLst>
+              <a:ext uri="{FF2B5EF4-FFF2-40B4-BE49-F238E27FC236}">
+                <a16:creationId xmlns:a16="http://schemas.microsoft.com/office/drawing/2014/main" id="{2EF78F5F-07B2-18CA-55A7-FB49AB081A52}"/>
+              </a:ext>
+            </a:extLst>
+          </p:cNvPr>
+          <p:cNvSpPr/>
+          <p:nvPr/>
+        </p:nvSpPr>
+        <p:spPr>
+          <a:xfrm>
+            <a:off x="320040" y="1956816"/>
+            <a:ext cx="502920" cy="850392"/>
+          </a:xfrm>
+          <a:prstGeom prst="rect">
+            <a:avLst/>
+          </a:prstGeom>
+          <a:noFill/>
+          <a:ln/>
+        </p:spPr>
+        <p:txBody>
+          <a:bodyPr wrap="square" lIns="0" tIns="0" rIns="0" bIns="0" rtlCol="0" anchor="ctr"/>
+          <a:lstStyle/>
+          <a:p>
+            <a:pPr marL="0" indent="0" algn="ctr">
+              <a:buNone/>
+            </a:pPr>
+            <a:r>
+              <a:rPr lang="en-US" sz="1800" b="1" dirty="0">
+                <a:solidFill>
+                  <a:srgbClr val="FFFFFF"/>
+                </a:solidFill>
+                <a:latin typeface="Calibri" pitchFamily="34" charset="0"/>
+                <a:ea typeface="Calibri" pitchFamily="34" charset="-122"/>
+                <a:cs typeface="Calibri" pitchFamily="34" charset="-120"/>
+              </a:rPr>
+              <a:t>2</a:t>
+            </a:r>
+            <a:endParaRPr lang="en-US" sz="1800" dirty="0"/>
+          </a:p>
+        </p:txBody>
+      </p:sp>
+      <p:sp>
+        <p:nvSpPr>
+          <p:cNvPr id="12" name="Text 10">
+            <a:extLst>
+              <a:ext uri="{FF2B5EF4-FFF2-40B4-BE49-F238E27FC236}">
+                <a16:creationId xmlns:a16="http://schemas.microsoft.com/office/drawing/2014/main" id="{851A0E89-B6C3-2212-B214-F644B94A9257}"/>
+              </a:ext>
+            </a:extLst>
+          </p:cNvPr>
+          <p:cNvSpPr/>
+          <p:nvPr/>
+        </p:nvSpPr>
+        <p:spPr>
+          <a:xfrm>
+            <a:off x="914400" y="2011680"/>
+            <a:ext cx="2468880" cy="237744"/>
+          </a:xfrm>
+          <a:prstGeom prst="rect">
+            <a:avLst/>
+          </a:prstGeom>
+          <a:noFill/>
+          <a:ln/>
+        </p:spPr>
+        <p:txBody>
+          <a:bodyPr wrap="square" lIns="0" tIns="0" rIns="0" bIns="0" rtlCol="0" anchor="ctr"/>
+          <a:lstStyle/>
+          <a:p>
+            <a:pPr marL="0" indent="0" algn="l">
+              <a:buNone/>
+            </a:pPr>
+            <a:r>
+              <a:rPr lang="en-US" sz="1100" b="1" dirty="0">
+                <a:solidFill>
+                  <a:srgbClr val="1E3A8A"/>
+                </a:solidFill>
+                <a:latin typeface="Calibri" pitchFamily="34" charset="0"/>
+                <a:ea typeface="Calibri" pitchFamily="34" charset="-122"/>
+                <a:cs typeface="Calibri" pitchFamily="34" charset="-120"/>
+              </a:rPr>
+              <a:t>Compute base parameters from history</a:t>
+            </a:r>
+            <a:endParaRPr lang="en-US" sz="1100" dirty="0"/>
+          </a:p>
+        </p:txBody>
+      </p:sp>
+      <p:sp>
+        <p:nvSpPr>
+          <p:cNvPr id="13" name="Text 11">
+            <a:extLst>
+              <a:ext uri="{FF2B5EF4-FFF2-40B4-BE49-F238E27FC236}">
+                <a16:creationId xmlns:a16="http://schemas.microsoft.com/office/drawing/2014/main" id="{60B02776-AB15-2C41-68DE-39E9566FC91E}"/>
+              </a:ext>
+            </a:extLst>
+          </p:cNvPr>
+          <p:cNvSpPr/>
+          <p:nvPr/>
+        </p:nvSpPr>
+        <p:spPr>
+          <a:xfrm>
+            <a:off x="914400" y="2267712"/>
+            <a:ext cx="2286000" cy="530352"/>
+          </a:xfrm>
+          <a:prstGeom prst="rect">
+            <a:avLst/>
+          </a:prstGeom>
+          <a:noFill/>
+          <a:ln/>
+        </p:spPr>
+        <p:txBody>
+          <a:bodyPr wrap="square" lIns="0" tIns="0" rIns="0" bIns="0" rtlCol="0" anchor="t"/>
+          <a:lstStyle/>
+          <a:p>
+            <a:pPr marL="0" indent="0" algn="l">
+              <a:buNone/>
+            </a:pPr>
+            <a:r>
+              <a:rPr lang="en-US" sz="950" dirty="0">
+                <a:solidFill>
+                  <a:srgbClr val="0F172A"/>
+                </a:solidFill>
+                <a:latin typeface="Calibri" pitchFamily="34" charset="0"/>
+                <a:ea typeface="Calibri" pitchFamily="34" charset="-122"/>
+                <a:cs typeface="Calibri" pitchFamily="34" charset="-120"/>
+              </a:rPr>
+              <a:t>At the smallest observed N (n_min):</a:t>
+            </a:r>
+            <a:endParaRPr lang="en-US" sz="950" dirty="0"/>
+          </a:p>
+        </p:txBody>
+      </p:sp>
+      <p:sp>
+        <p:nvSpPr>
+          <p:cNvPr id="14" name="Shape 12">
+            <a:extLst>
+              <a:ext uri="{FF2B5EF4-FFF2-40B4-BE49-F238E27FC236}">
+                <a16:creationId xmlns:a16="http://schemas.microsoft.com/office/drawing/2014/main" id="{51269B5E-46E2-26A1-BAD5-481B26CFC0E4}"/>
+              </a:ext>
+            </a:extLst>
+          </p:cNvPr>
+          <p:cNvSpPr/>
+          <p:nvPr/>
+        </p:nvSpPr>
+        <p:spPr>
+          <a:xfrm>
+            <a:off x="3429000" y="2011680"/>
+            <a:ext cx="5257800" cy="740664"/>
+          </a:xfrm>
+          <a:prstGeom prst="rect">
+            <a:avLst/>
+          </a:prstGeom>
+          <a:solidFill>
+            <a:srgbClr val="FFFFFF"/>
+          </a:solidFill>
+          <a:ln w="6350">
+            <a:solidFill>
+              <a:srgbClr val="3B82F6"/>
+            </a:solidFill>
+            <a:prstDash val="solid"/>
+          </a:ln>
+        </p:spPr>
+        <p:txBody>
+          <a:bodyPr/>
+          <a:lstStyle/>
+          <a:p>
+            <a:endParaRPr lang="en-US"/>
+          </a:p>
+        </p:txBody>
+      </p:sp>
+      <p:sp>
+        <p:nvSpPr>
+          <p:cNvPr id="15" name="Text 13">
+            <a:extLst>
+              <a:ext uri="{FF2B5EF4-FFF2-40B4-BE49-F238E27FC236}">
+                <a16:creationId xmlns:a16="http://schemas.microsoft.com/office/drawing/2014/main" id="{E4FAB64F-48A5-6F09-38F2-24238E00CC9F}"/>
+              </a:ext>
+            </a:extLst>
+          </p:cNvPr>
+          <p:cNvSpPr/>
+          <p:nvPr/>
+        </p:nvSpPr>
+        <p:spPr>
+          <a:xfrm>
+            <a:off x="3520440" y="2029968"/>
+            <a:ext cx="5074920" cy="704088"/>
+          </a:xfrm>
+          <a:prstGeom prst="rect">
+            <a:avLst/>
+          </a:prstGeom>
+          <a:noFill/>
+          <a:ln/>
+        </p:spPr>
+        <p:txBody>
+          <a:bodyPr wrap="square" lIns="0" tIns="0" rIns="0" bIns="0" rtlCol="0" anchor="t"/>
+          <a:lstStyle/>
+          <a:p>
+            <a:pPr marL="0" indent="0" algn="l">
+              <a:buNone/>
+            </a:pPr>
+            <a:r>
+              <a:rPr lang="en-US" sz="850" dirty="0">
+                <a:solidFill>
+                  <a:srgbClr val="1E3A8A"/>
+                </a:solidFill>
+                <a:latin typeface="Consolas" pitchFamily="34" charset="0"/>
+                <a:ea typeface="Consolas" pitchFamily="34" charset="-122"/>
+                <a:cs typeface="Consolas" pitchFamily="34" charset="-120"/>
+              </a:rPr>
+              <a:t>W = avg(T_k × P_k)          total work (samples), constant per workload</a:t>
+            </a:r>
+            <a:endParaRPr lang="en-US" sz="850" dirty="0"/>
+          </a:p>
+          <a:p>
+            <a:pPr marL="0" indent="0" algn="l">
+              <a:buNone/>
+            </a:pPr>
+            <a:r>
+              <a:rPr lang="en-US" sz="850" dirty="0">
+                <a:solidFill>
+                  <a:srgbClr val="1E3A8A"/>
+                </a:solidFill>
+                <a:latin typeface="Consolas" pitchFamily="34" charset="0"/>
+                <a:ea typeface="Consolas" pitchFamily="34" charset="-122"/>
+                <a:cs typeface="Consolas" pitchFamily="34" charset="-120"/>
+              </a:rPr>
+              <a:t>p0 = avg(P_k) / n_min       per-node baseline throughput</a:t>
+            </a:r>
+            <a:endParaRPr lang="en-US" sz="850" dirty="0"/>
+          </a:p>
+          <a:p>
+            <a:pPr marL="0" indent="0" algn="l">
+              <a:buNone/>
+            </a:pPr>
+            <a:r>
+              <a:rPr lang="en-US" sz="850" dirty="0">
+                <a:solidFill>
+                  <a:srgbClr val="1E3A8A"/>
+                </a:solidFill>
+                <a:latin typeface="Consolas" pitchFamily="34" charset="0"/>
+                <a:ea typeface="Consolas" pitchFamily="34" charset="-122"/>
+                <a:cs typeface="Consolas" pitchFamily="34" charset="-120"/>
+              </a:rPr>
+              <a:t>T_prov = avg(provisioning_s) average provisioning time</a:t>
+            </a:r>
+          </a:p>
+          <a:p>
+            <a:pPr marL="0" indent="0" algn="l">
+              <a:buNone/>
+            </a:pPr>
+            <a:endParaRPr lang="en-US" sz="850" dirty="0"/>
+          </a:p>
+        </p:txBody>
+      </p:sp>
+      <p:sp>
+        <p:nvSpPr>
+          <p:cNvPr id="16" name="Shape 14">
+            <a:extLst>
+              <a:ext uri="{FF2B5EF4-FFF2-40B4-BE49-F238E27FC236}">
+                <a16:creationId xmlns:a16="http://schemas.microsoft.com/office/drawing/2014/main" id="{4F843411-EA17-20AE-F3B5-9B704B53D263}"/>
+              </a:ext>
+            </a:extLst>
+          </p:cNvPr>
+          <p:cNvSpPr/>
+          <p:nvPr/>
+        </p:nvSpPr>
+        <p:spPr>
+          <a:xfrm>
+            <a:off x="320040" y="2862072"/>
+            <a:ext cx="8503920" cy="850392"/>
+          </a:xfrm>
+          <a:prstGeom prst="rect">
+            <a:avLst/>
+          </a:prstGeom>
+          <a:solidFill>
+            <a:srgbClr val="DBEAFE"/>
+          </a:solidFill>
+          <a:ln w="6350">
+            <a:solidFill>
+              <a:srgbClr val="3B82F6"/>
+            </a:solidFill>
+            <a:prstDash val="solid"/>
+          </a:ln>
+        </p:spPr>
+        <p:txBody>
+          <a:bodyPr/>
+          <a:lstStyle/>
+          <a:p>
+            <a:endParaRPr lang="en-US"/>
+          </a:p>
+        </p:txBody>
+      </p:sp>
+      <p:sp>
+        <p:nvSpPr>
+          <p:cNvPr id="17" name="Shape 15">
+            <a:extLst>
+              <a:ext uri="{FF2B5EF4-FFF2-40B4-BE49-F238E27FC236}">
+                <a16:creationId xmlns:a16="http://schemas.microsoft.com/office/drawing/2014/main" id="{C34145AD-3995-B631-FB30-B30DA23646C2}"/>
+              </a:ext>
+            </a:extLst>
+          </p:cNvPr>
+          <p:cNvSpPr/>
+          <p:nvPr/>
+        </p:nvSpPr>
+        <p:spPr>
+          <a:xfrm>
+            <a:off x="320040" y="2862072"/>
+            <a:ext cx="502920" cy="850392"/>
+          </a:xfrm>
+          <a:prstGeom prst="rect">
+            <a:avLst/>
+          </a:prstGeom>
+          <a:solidFill>
+            <a:srgbClr val="1D4ED8"/>
+          </a:solidFill>
+          <a:ln w="12700">
+            <a:solidFill>
+              <a:srgbClr val="1D4ED8"/>
+            </a:solidFill>
+            <a:prstDash val="solid"/>
+          </a:ln>
+        </p:spPr>
+        <p:txBody>
+          <a:bodyPr/>
+          <a:lstStyle/>
+          <a:p>
+            <a:endParaRPr lang="en-US"/>
+          </a:p>
+        </p:txBody>
+      </p:sp>
+      <p:sp>
+        <p:nvSpPr>
+          <p:cNvPr id="18" name="Text 16">
+            <a:extLst>
+              <a:ext uri="{FF2B5EF4-FFF2-40B4-BE49-F238E27FC236}">
+                <a16:creationId xmlns:a16="http://schemas.microsoft.com/office/drawing/2014/main" id="{96C841D7-2A8F-871D-70D7-616A693513BA}"/>
+              </a:ext>
+            </a:extLst>
+          </p:cNvPr>
+          <p:cNvSpPr/>
+          <p:nvPr/>
+        </p:nvSpPr>
+        <p:spPr>
+          <a:xfrm>
+            <a:off x="320040" y="2862072"/>
+            <a:ext cx="502920" cy="850392"/>
+          </a:xfrm>
+          <a:prstGeom prst="rect">
+            <a:avLst/>
+          </a:prstGeom>
+          <a:noFill/>
+          <a:ln/>
+        </p:spPr>
+        <p:txBody>
+          <a:bodyPr wrap="square" lIns="0" tIns="0" rIns="0" bIns="0" rtlCol="0" anchor="ctr"/>
+          <a:lstStyle/>
+          <a:p>
+            <a:pPr marL="0" indent="0" algn="ctr">
+              <a:buNone/>
+            </a:pPr>
+            <a:r>
+              <a:rPr lang="en-US" sz="1800" b="1" dirty="0">
+                <a:solidFill>
+                  <a:srgbClr val="FFFFFF"/>
+                </a:solidFill>
+                <a:latin typeface="Calibri" pitchFamily="34" charset="0"/>
+                <a:ea typeface="Calibri" pitchFamily="34" charset="-122"/>
+                <a:cs typeface="Calibri" pitchFamily="34" charset="-120"/>
+              </a:rPr>
+              <a:t>3</a:t>
+            </a:r>
+            <a:endParaRPr lang="en-US" sz="1800" dirty="0"/>
+          </a:p>
+        </p:txBody>
+      </p:sp>
+      <p:sp>
+        <p:nvSpPr>
+          <p:cNvPr id="19" name="Text 17">
+            <a:extLst>
+              <a:ext uri="{FF2B5EF4-FFF2-40B4-BE49-F238E27FC236}">
+                <a16:creationId xmlns:a16="http://schemas.microsoft.com/office/drawing/2014/main" id="{8E8A3124-1289-B6AE-8399-E1A68B7FE023}"/>
+              </a:ext>
+            </a:extLst>
+          </p:cNvPr>
+          <p:cNvSpPr/>
+          <p:nvPr/>
+        </p:nvSpPr>
+        <p:spPr>
+          <a:xfrm>
+            <a:off x="914400" y="2916936"/>
+            <a:ext cx="2468880" cy="237744"/>
+          </a:xfrm>
+          <a:prstGeom prst="rect">
+            <a:avLst/>
+          </a:prstGeom>
+          <a:noFill/>
+          <a:ln/>
+        </p:spPr>
+        <p:txBody>
+          <a:bodyPr wrap="square" lIns="0" tIns="0" rIns="0" bIns="0" rtlCol="0" anchor="ctr"/>
+          <a:lstStyle/>
+          <a:p>
+            <a:pPr marL="0" indent="0" algn="l">
+              <a:buNone/>
+            </a:pPr>
+            <a:r>
+              <a:rPr lang="en-US" sz="1100" b="1" dirty="0">
+                <a:solidFill>
+                  <a:srgbClr val="1E3A8A"/>
+                </a:solidFill>
+                <a:latin typeface="Calibri" pitchFamily="34" charset="0"/>
+                <a:ea typeface="Calibri" pitchFamily="34" charset="-122"/>
+                <a:cs typeface="Calibri" pitchFamily="34" charset="-120"/>
+              </a:rPr>
+              <a:t>Fit alpha — scaling overhead</a:t>
+            </a:r>
+            <a:endParaRPr lang="en-US" sz="1100" dirty="0"/>
+          </a:p>
+        </p:txBody>
+      </p:sp>
+      <p:sp>
+        <p:nvSpPr>
+          <p:cNvPr id="20" name="Text 18">
+            <a:extLst>
+              <a:ext uri="{FF2B5EF4-FFF2-40B4-BE49-F238E27FC236}">
+                <a16:creationId xmlns:a16="http://schemas.microsoft.com/office/drawing/2014/main" id="{2C41CA76-100D-603D-CF39-BA41AD0102B6}"/>
+              </a:ext>
+            </a:extLst>
+          </p:cNvPr>
+          <p:cNvSpPr/>
+          <p:nvPr/>
+        </p:nvSpPr>
+        <p:spPr>
+          <a:xfrm>
+            <a:off x="914400" y="3172968"/>
+            <a:ext cx="2286000" cy="530352"/>
+          </a:xfrm>
+          <a:prstGeom prst="rect">
+            <a:avLst/>
+          </a:prstGeom>
+          <a:noFill/>
+          <a:ln/>
+        </p:spPr>
+        <p:txBody>
+          <a:bodyPr wrap="square" lIns="0" tIns="0" rIns="0" bIns="0" rtlCol="0" anchor="t"/>
+          <a:lstStyle/>
+          <a:p>
+            <a:pPr marL="0" indent="0" algn="l">
+              <a:buNone/>
+            </a:pPr>
+            <a:r>
+              <a:rPr lang="en-US" sz="950" dirty="0">
+                <a:solidFill>
+                  <a:srgbClr val="0F172A"/>
+                </a:solidFill>
+                <a:latin typeface="Calibri" pitchFamily="34" charset="0"/>
+                <a:ea typeface="Calibri" pitchFamily="34" charset="-122"/>
+                <a:cs typeface="Calibri" pitchFamily="34" charset="-120"/>
+              </a:rPr>
+              <a:t>How fast efficiency decays as more nodes are added (</a:t>
+            </a:r>
+            <a:r>
+              <a:rPr lang="en-US" sz="950" dirty="0" err="1">
+                <a:solidFill>
+                  <a:srgbClr val="0F172A"/>
+                </a:solidFill>
+                <a:latin typeface="Calibri" pitchFamily="34" charset="0"/>
+                <a:ea typeface="Calibri" pitchFamily="34" charset="-122"/>
+                <a:cs typeface="Calibri" pitchFamily="34" charset="-120"/>
+              </a:rPr>
+              <a:t>gloo</a:t>
+            </a:r>
+            <a:r>
+              <a:rPr lang="en-US" sz="950" dirty="0">
+                <a:solidFill>
+                  <a:srgbClr val="0F172A"/>
+                </a:solidFill>
+                <a:latin typeface="Calibri" pitchFamily="34" charset="0"/>
+                <a:ea typeface="Calibri" pitchFamily="34" charset="-122"/>
+                <a:cs typeface="Calibri" pitchFamily="34" charset="-120"/>
+              </a:rPr>
+              <a:t> backend communication cost):</a:t>
+            </a:r>
+            <a:endParaRPr lang="en-US" sz="950" dirty="0"/>
+          </a:p>
+        </p:txBody>
+      </p:sp>
+      <p:sp>
+        <p:nvSpPr>
+          <p:cNvPr id="21" name="Shape 19">
+            <a:extLst>
+              <a:ext uri="{FF2B5EF4-FFF2-40B4-BE49-F238E27FC236}">
+                <a16:creationId xmlns:a16="http://schemas.microsoft.com/office/drawing/2014/main" id="{4FFA7450-5CA1-810F-FD02-C43ABB07FF2F}"/>
+              </a:ext>
+            </a:extLst>
+          </p:cNvPr>
+          <p:cNvSpPr/>
+          <p:nvPr/>
+        </p:nvSpPr>
+        <p:spPr>
+          <a:xfrm>
+            <a:off x="3429000" y="2916936"/>
+            <a:ext cx="5257800" cy="740664"/>
+          </a:xfrm>
+          <a:prstGeom prst="rect">
+            <a:avLst/>
+          </a:prstGeom>
+          <a:solidFill>
+            <a:srgbClr val="FFFFFF"/>
+          </a:solidFill>
+          <a:ln w="6350">
+            <a:solidFill>
+              <a:srgbClr val="3B82F6"/>
+            </a:solidFill>
+            <a:prstDash val="solid"/>
+          </a:ln>
+        </p:spPr>
+        <p:txBody>
+          <a:bodyPr/>
+          <a:lstStyle/>
+          <a:p>
+            <a:endParaRPr lang="en-US"/>
+          </a:p>
+        </p:txBody>
+      </p:sp>
+      <p:sp>
+        <p:nvSpPr>
+          <p:cNvPr id="22" name="Text 20">
+            <a:extLst>
+              <a:ext uri="{FF2B5EF4-FFF2-40B4-BE49-F238E27FC236}">
+                <a16:creationId xmlns:a16="http://schemas.microsoft.com/office/drawing/2014/main" id="{6A4A122F-60A3-9C4D-1E4B-E430D3CC773C}"/>
+              </a:ext>
+            </a:extLst>
+          </p:cNvPr>
+          <p:cNvSpPr/>
+          <p:nvPr/>
+        </p:nvSpPr>
+        <p:spPr>
+          <a:xfrm>
+            <a:off x="3520440" y="2935224"/>
+            <a:ext cx="5074920" cy="704088"/>
+          </a:xfrm>
+          <a:prstGeom prst="rect">
+            <a:avLst/>
+          </a:prstGeom>
+          <a:noFill/>
+          <a:ln/>
+        </p:spPr>
+        <p:txBody>
+          <a:bodyPr wrap="square" lIns="0" tIns="0" rIns="0" bIns="0" rtlCol="0" anchor="t"/>
+          <a:lstStyle/>
+          <a:p>
+            <a:pPr marL="0" indent="0" algn="l">
+              <a:buNone/>
+            </a:pPr>
+            <a:r>
+              <a:rPr lang="en-US" sz="850" dirty="0">
+                <a:solidFill>
+                  <a:srgbClr val="1E3A8A"/>
+                </a:solidFill>
+                <a:latin typeface="Consolas" pitchFamily="34" charset="0"/>
+                <a:ea typeface="Consolas" pitchFamily="34" charset="-122"/>
+                <a:cs typeface="Consolas" pitchFamily="34" charset="-120"/>
+              </a:rPr>
+              <a:t>1 distinct N  →  alpha = 0   (linear scaling assumed)</a:t>
+            </a:r>
+            <a:endParaRPr lang="en-US" sz="850" dirty="0"/>
+          </a:p>
+          <a:p>
+            <a:pPr marL="0" indent="0" algn="l">
+              <a:buNone/>
+            </a:pPr>
+            <a:r>
+              <a:rPr lang="en-US" sz="850" dirty="0">
+                <a:solidFill>
+                  <a:srgbClr val="1E3A8A"/>
+                </a:solidFill>
+                <a:latin typeface="Consolas" pitchFamily="34" charset="0"/>
+                <a:ea typeface="Consolas" pitchFamily="34" charset="-122"/>
+                <a:cs typeface="Consolas" pitchFamily="34" charset="-120"/>
+              </a:rPr>
+              <a:t>2 distinct N  →  </a:t>
+            </a:r>
+            <a:r>
+              <a:rPr lang="en-US" sz="850" dirty="0" err="1">
+                <a:solidFill>
+                  <a:srgbClr val="1E3A8A"/>
+                </a:solidFill>
+                <a:latin typeface="Consolas" pitchFamily="34" charset="0"/>
+                <a:ea typeface="Consolas" pitchFamily="34" charset="-122"/>
+                <a:cs typeface="Consolas" pitchFamily="34" charset="-120"/>
+              </a:rPr>
+              <a:t>observed_eta</a:t>
+            </a:r>
+            <a:r>
+              <a:rPr lang="en-US" sz="850" dirty="0">
+                <a:solidFill>
+                  <a:srgbClr val="1E3A8A"/>
+                </a:solidFill>
+                <a:latin typeface="Consolas" pitchFamily="34" charset="0"/>
+                <a:ea typeface="Consolas" pitchFamily="34" charset="-122"/>
+                <a:cs typeface="Consolas" pitchFamily="34" charset="-120"/>
+              </a:rPr>
+              <a:t> = (P2/n2)/(P1/n1)   // actual parallel efficiency</a:t>
+            </a:r>
+            <a:endParaRPr lang="en-US" sz="850" dirty="0"/>
+          </a:p>
+          <a:p>
+            <a:r>
+              <a:rPr lang="en-US" sz="850" dirty="0">
+                <a:solidFill>
+                  <a:srgbClr val="1E3A8A"/>
+                </a:solidFill>
+                <a:latin typeface="Consolas" pitchFamily="34" charset="0"/>
+                <a:ea typeface="Consolas" pitchFamily="34" charset="-122"/>
+                <a:cs typeface="Consolas" pitchFamily="34" charset="-120"/>
+              </a:rPr>
+              <a:t>              →  alpha = (1 - </a:t>
+            </a:r>
+            <a:r>
+              <a:rPr lang="en-US" sz="850" dirty="0" err="1">
+                <a:solidFill>
+                  <a:srgbClr val="1E3A8A"/>
+                </a:solidFill>
+                <a:latin typeface="Consolas" pitchFamily="34" charset="0"/>
+                <a:ea typeface="Consolas" pitchFamily="34" charset="-122"/>
+                <a:cs typeface="Consolas" pitchFamily="34" charset="-120"/>
+              </a:rPr>
+              <a:t>observed_eta</a:t>
+            </a:r>
+            <a:r>
+              <a:rPr lang="en-US" sz="850" dirty="0">
+                <a:solidFill>
+                  <a:srgbClr val="1E3A8A"/>
+                </a:solidFill>
+                <a:latin typeface="Consolas" pitchFamily="34" charset="0"/>
+                <a:ea typeface="Consolas" pitchFamily="34" charset="-122"/>
+                <a:cs typeface="Consolas" pitchFamily="34" charset="-120"/>
+              </a:rPr>
+              <a:t> ) / (</a:t>
+            </a:r>
+            <a:r>
+              <a:rPr lang="en-US" sz="850" dirty="0" err="1">
+                <a:solidFill>
+                  <a:srgbClr val="1E3A8A"/>
+                </a:solidFill>
+                <a:latin typeface="Consolas" pitchFamily="34" charset="0"/>
+                <a:ea typeface="Consolas" pitchFamily="34" charset="-122"/>
+                <a:cs typeface="Consolas" pitchFamily="34" charset="-120"/>
+              </a:rPr>
+              <a:t>observed_eta</a:t>
+            </a:r>
+            <a:r>
+              <a:rPr lang="en-US" sz="850" dirty="0">
+                <a:solidFill>
+                  <a:srgbClr val="1E3A8A"/>
+                </a:solidFill>
+                <a:latin typeface="Consolas" pitchFamily="34" charset="0"/>
+                <a:ea typeface="Consolas" pitchFamily="34" charset="-122"/>
+                <a:cs typeface="Consolas" pitchFamily="34" charset="-120"/>
+              </a:rPr>
+              <a:t> * (n2-n1))</a:t>
+            </a:r>
+            <a:endParaRPr lang="en-US" sz="850" dirty="0"/>
+          </a:p>
+          <a:p>
+            <a:pPr marL="0" indent="0" algn="l">
+              <a:buNone/>
+            </a:pPr>
+            <a:r>
+              <a:rPr lang="en-US" sz="850" dirty="0">
+                <a:solidFill>
+                  <a:srgbClr val="1E3A8A"/>
+                </a:solidFill>
+                <a:latin typeface="Consolas" pitchFamily="34" charset="0"/>
+                <a:ea typeface="Consolas" pitchFamily="34" charset="-122"/>
+                <a:cs typeface="Consolas" pitchFamily="34" charset="-120"/>
+              </a:rPr>
+              <a:t>3+ distinct N →  argmin_alpha  sum[ (P(n) - p0*n*eta(n,alpha))^2 ]</a:t>
+            </a:r>
+            <a:endParaRPr lang="en-US" sz="850" dirty="0"/>
+          </a:p>
+        </p:txBody>
+      </p:sp>
+      <p:sp>
+        <p:nvSpPr>
+          <p:cNvPr id="23" name="Shape 21">
+            <a:extLst>
+              <a:ext uri="{FF2B5EF4-FFF2-40B4-BE49-F238E27FC236}">
+                <a16:creationId xmlns:a16="http://schemas.microsoft.com/office/drawing/2014/main" id="{9AF94911-02BE-007A-7C3A-777DE76B9810}"/>
+              </a:ext>
+            </a:extLst>
+          </p:cNvPr>
+          <p:cNvSpPr/>
+          <p:nvPr/>
+        </p:nvSpPr>
+        <p:spPr>
+          <a:xfrm>
+            <a:off x="320040" y="3767328"/>
+            <a:ext cx="8503920" cy="850392"/>
+          </a:xfrm>
+          <a:prstGeom prst="rect">
+            <a:avLst/>
+          </a:prstGeom>
+          <a:solidFill>
+            <a:srgbClr val="DBEAFE"/>
+          </a:solidFill>
+          <a:ln w="6350">
+            <a:solidFill>
+              <a:srgbClr val="3B82F6"/>
+            </a:solidFill>
+            <a:prstDash val="solid"/>
+          </a:ln>
+        </p:spPr>
+        <p:txBody>
+          <a:bodyPr/>
+          <a:lstStyle/>
+          <a:p>
+            <a:endParaRPr lang="en-US"/>
+          </a:p>
+        </p:txBody>
+      </p:sp>
+      <p:sp>
+        <p:nvSpPr>
+          <p:cNvPr id="24" name="Shape 22">
+            <a:extLst>
+              <a:ext uri="{FF2B5EF4-FFF2-40B4-BE49-F238E27FC236}">
+                <a16:creationId xmlns:a16="http://schemas.microsoft.com/office/drawing/2014/main" id="{D3BEFAD1-78B9-5641-C09D-BA639DC9DA84}"/>
+              </a:ext>
+            </a:extLst>
+          </p:cNvPr>
+          <p:cNvSpPr/>
+          <p:nvPr/>
+        </p:nvSpPr>
+        <p:spPr>
+          <a:xfrm>
+            <a:off x="320040" y="3767328"/>
+            <a:ext cx="502920" cy="850392"/>
+          </a:xfrm>
+          <a:prstGeom prst="rect">
+            <a:avLst/>
+          </a:prstGeom>
+          <a:solidFill>
+            <a:srgbClr val="1D4ED8"/>
+          </a:solidFill>
+          <a:ln w="12700">
+            <a:solidFill>
+              <a:srgbClr val="1D4ED8"/>
+            </a:solidFill>
+            <a:prstDash val="solid"/>
+          </a:ln>
+        </p:spPr>
+        <p:txBody>
+          <a:bodyPr/>
+          <a:lstStyle/>
+          <a:p>
+            <a:endParaRPr lang="en-US"/>
+          </a:p>
+        </p:txBody>
+      </p:sp>
+      <p:sp>
+        <p:nvSpPr>
+          <p:cNvPr id="25" name="Text 23">
+            <a:extLst>
+              <a:ext uri="{FF2B5EF4-FFF2-40B4-BE49-F238E27FC236}">
+                <a16:creationId xmlns:a16="http://schemas.microsoft.com/office/drawing/2014/main" id="{C1AFCD22-10B3-B6C4-56B7-0F5268A8E747}"/>
+              </a:ext>
+            </a:extLst>
+          </p:cNvPr>
+          <p:cNvSpPr/>
+          <p:nvPr/>
+        </p:nvSpPr>
+        <p:spPr>
+          <a:xfrm>
+            <a:off x="320040" y="3767328"/>
+            <a:ext cx="502920" cy="850392"/>
+          </a:xfrm>
+          <a:prstGeom prst="rect">
+            <a:avLst/>
+          </a:prstGeom>
+          <a:noFill/>
+          <a:ln/>
+        </p:spPr>
+        <p:txBody>
+          <a:bodyPr wrap="square" lIns="0" tIns="0" rIns="0" bIns="0" rtlCol="0" anchor="ctr"/>
+          <a:lstStyle/>
+          <a:p>
+            <a:pPr marL="0" indent="0" algn="ctr">
+              <a:buNone/>
+            </a:pPr>
+            <a:r>
+              <a:rPr lang="en-US" sz="1800" b="1" dirty="0">
+                <a:solidFill>
+                  <a:srgbClr val="FFFFFF"/>
+                </a:solidFill>
+                <a:latin typeface="Calibri" pitchFamily="34" charset="0"/>
+                <a:ea typeface="Calibri" pitchFamily="34" charset="-122"/>
+                <a:cs typeface="Calibri" pitchFamily="34" charset="-120"/>
+              </a:rPr>
+              <a:t>4</a:t>
+            </a:r>
+            <a:endParaRPr lang="en-US" sz="1800" dirty="0"/>
+          </a:p>
+        </p:txBody>
+      </p:sp>
+      <p:sp>
+        <p:nvSpPr>
+          <p:cNvPr id="26" name="Text 24">
+            <a:extLst>
+              <a:ext uri="{FF2B5EF4-FFF2-40B4-BE49-F238E27FC236}">
+                <a16:creationId xmlns:a16="http://schemas.microsoft.com/office/drawing/2014/main" id="{9F29E840-14C9-6F00-29C6-8FCB2F35E882}"/>
+              </a:ext>
+            </a:extLst>
+          </p:cNvPr>
+          <p:cNvSpPr/>
+          <p:nvPr/>
+        </p:nvSpPr>
+        <p:spPr>
+          <a:xfrm>
+            <a:off x="914400" y="3822192"/>
+            <a:ext cx="2468880" cy="237744"/>
+          </a:xfrm>
+          <a:prstGeom prst="rect">
+            <a:avLst/>
+          </a:prstGeom>
+          <a:noFill/>
+          <a:ln/>
+        </p:spPr>
+        <p:txBody>
+          <a:bodyPr wrap="square" lIns="0" tIns="0" rIns="0" bIns="0" rtlCol="0" anchor="ctr"/>
+          <a:lstStyle/>
+          <a:p>
+            <a:pPr marL="0" indent="0" algn="l">
+              <a:buNone/>
+            </a:pPr>
+            <a:r>
+              <a:rPr lang="en-US" sz="1100" b="1" dirty="0">
+                <a:solidFill>
+                  <a:srgbClr val="1E3A8A"/>
+                </a:solidFill>
+                <a:latin typeface="Calibri" pitchFamily="34" charset="0"/>
+                <a:ea typeface="Calibri" pitchFamily="34" charset="-122"/>
+                <a:cs typeface="Calibri" pitchFamily="34" charset="-120"/>
+              </a:rPr>
+              <a:t>Predict T(n) and Cost(n), then select N</a:t>
+            </a:r>
+            <a:endParaRPr lang="en-US" sz="1100" dirty="0"/>
+          </a:p>
+        </p:txBody>
+      </p:sp>
+      <p:sp>
+        <p:nvSpPr>
+          <p:cNvPr id="27" name="Text 25">
+            <a:extLst>
+              <a:ext uri="{FF2B5EF4-FFF2-40B4-BE49-F238E27FC236}">
+                <a16:creationId xmlns:a16="http://schemas.microsoft.com/office/drawing/2014/main" id="{6656AA96-0E41-2FFA-F38A-550D41F423FF}"/>
+              </a:ext>
+            </a:extLst>
+          </p:cNvPr>
+          <p:cNvSpPr/>
+          <p:nvPr/>
+        </p:nvSpPr>
+        <p:spPr>
+          <a:xfrm>
+            <a:off x="914400" y="4078224"/>
+            <a:ext cx="2286000" cy="530352"/>
+          </a:xfrm>
+          <a:prstGeom prst="rect">
+            <a:avLst/>
+          </a:prstGeom>
+          <a:noFill/>
+          <a:ln/>
+        </p:spPr>
+        <p:txBody>
+          <a:bodyPr wrap="square" lIns="0" tIns="0" rIns="0" bIns="0" rtlCol="0" anchor="t"/>
+          <a:lstStyle/>
+          <a:p>
+            <a:pPr marL="0" indent="0" algn="l">
+              <a:buNone/>
+            </a:pPr>
+            <a:r>
+              <a:rPr lang="en-US" sz="950" dirty="0">
+                <a:solidFill>
+                  <a:srgbClr val="0F172A"/>
+                </a:solidFill>
+                <a:latin typeface="Calibri" pitchFamily="34" charset="0"/>
+                <a:ea typeface="Calibri" pitchFamily="34" charset="-122"/>
+                <a:cs typeface="Calibri" pitchFamily="34" charset="-120"/>
+              </a:rPr>
+              <a:t>For each candidate n compute predicted time and cost, then pick the smallest n that meets the Objective:</a:t>
+            </a:r>
+            <a:endParaRPr lang="en-US" sz="950" dirty="0"/>
+          </a:p>
+        </p:txBody>
+      </p:sp>
+      <p:sp>
+        <p:nvSpPr>
+          <p:cNvPr id="28" name="Shape 26">
+            <a:extLst>
+              <a:ext uri="{FF2B5EF4-FFF2-40B4-BE49-F238E27FC236}">
+                <a16:creationId xmlns:a16="http://schemas.microsoft.com/office/drawing/2014/main" id="{FBAB2436-2271-DBDE-CDD1-83F75C5719BF}"/>
+              </a:ext>
+            </a:extLst>
+          </p:cNvPr>
+          <p:cNvSpPr/>
+          <p:nvPr/>
+        </p:nvSpPr>
+        <p:spPr>
+          <a:xfrm>
+            <a:off x="3429000" y="3822192"/>
+            <a:ext cx="5257800" cy="740664"/>
+          </a:xfrm>
+          <a:prstGeom prst="rect">
+            <a:avLst/>
+          </a:prstGeom>
+          <a:solidFill>
+            <a:srgbClr val="FFFFFF"/>
+          </a:solidFill>
+          <a:ln w="6350">
+            <a:solidFill>
+              <a:srgbClr val="3B82F6"/>
+            </a:solidFill>
+            <a:prstDash val="solid"/>
+          </a:ln>
+        </p:spPr>
+        <p:txBody>
+          <a:bodyPr/>
+          <a:lstStyle/>
+          <a:p>
+            <a:endParaRPr lang="en-US"/>
+          </a:p>
+        </p:txBody>
+      </p:sp>
+      <p:sp>
+        <p:nvSpPr>
+          <p:cNvPr id="29" name="Text 27">
+            <a:extLst>
+              <a:ext uri="{FF2B5EF4-FFF2-40B4-BE49-F238E27FC236}">
+                <a16:creationId xmlns:a16="http://schemas.microsoft.com/office/drawing/2014/main" id="{B7C0C8B5-2543-DDF8-3BCC-29E64E82AA5E}"/>
+              </a:ext>
+            </a:extLst>
+          </p:cNvPr>
+          <p:cNvSpPr/>
+          <p:nvPr/>
+        </p:nvSpPr>
+        <p:spPr>
+          <a:xfrm>
+            <a:off x="3520440" y="3840480"/>
+            <a:ext cx="5074920" cy="704088"/>
+          </a:xfrm>
+          <a:prstGeom prst="rect">
+            <a:avLst/>
+          </a:prstGeom>
+          <a:noFill/>
+          <a:ln/>
+        </p:spPr>
+        <p:txBody>
+          <a:bodyPr wrap="square" lIns="0" tIns="0" rIns="0" bIns="0" rtlCol="0" anchor="t"/>
+          <a:lstStyle/>
+          <a:p>
+            <a:pPr marL="0" indent="0" algn="l">
+              <a:buNone/>
+            </a:pPr>
+            <a:r>
+              <a:rPr lang="en-US" sz="850" dirty="0">
+                <a:solidFill>
+                  <a:srgbClr val="1E3A8A"/>
+                </a:solidFill>
+                <a:latin typeface="Consolas" pitchFamily="34" charset="0"/>
+                <a:ea typeface="Consolas" pitchFamily="34" charset="-122"/>
+                <a:cs typeface="Consolas" pitchFamily="34" charset="-120"/>
+              </a:rPr>
+              <a:t>eta(n) = 1/(1+alpha*(n-1))   predicted parallel efficiency</a:t>
+            </a:r>
+            <a:endParaRPr lang="en-US" sz="850" dirty="0"/>
+          </a:p>
+          <a:p>
+            <a:pPr marL="0" indent="0" algn="l">
+              <a:buNone/>
+            </a:pPr>
+            <a:r>
+              <a:rPr lang="en-US" sz="850" dirty="0">
+                <a:solidFill>
+                  <a:srgbClr val="1E3A8A"/>
+                </a:solidFill>
+                <a:latin typeface="Consolas" pitchFamily="34" charset="0"/>
+                <a:ea typeface="Consolas" pitchFamily="34" charset="-122"/>
+                <a:cs typeface="Consolas" pitchFamily="34" charset="-120"/>
+              </a:rPr>
+              <a:t>P(n)   = p0*n*eta(n)         predicted throughput</a:t>
+            </a:r>
+            <a:endParaRPr lang="en-US" sz="850" dirty="0"/>
+          </a:p>
+          <a:p>
+            <a:pPr marL="0" indent="0" algn="l">
+              <a:buNone/>
+            </a:pPr>
+            <a:r>
+              <a:rPr lang="en-US" sz="850" dirty="0">
+                <a:solidFill>
+                  <a:srgbClr val="1E3A8A"/>
+                </a:solidFill>
+                <a:latin typeface="Consolas" pitchFamily="34" charset="0"/>
+                <a:ea typeface="Consolas" pitchFamily="34" charset="-122"/>
+                <a:cs typeface="Consolas" pitchFamily="34" charset="-120"/>
+              </a:rPr>
+              <a:t>T(n)   = W/P(n)              predicted training time</a:t>
+            </a:r>
+            <a:endParaRPr lang="en-US" sz="850" dirty="0"/>
+          </a:p>
+          <a:p>
+            <a:pPr marL="0" indent="0" algn="l">
+              <a:buNone/>
+            </a:pPr>
+            <a:r>
+              <a:rPr lang="en-US" sz="850" dirty="0">
+                <a:solidFill>
+                  <a:srgbClr val="1E3A8A"/>
+                </a:solidFill>
+                <a:latin typeface="Consolas" pitchFamily="34" charset="0"/>
+                <a:ea typeface="Consolas" pitchFamily="34" charset="-122"/>
+                <a:cs typeface="Consolas" pitchFamily="34" charset="-120"/>
+              </a:rPr>
+              <a:t>Cost(n)   = C_h*n*(T(n)+T_prov)/3600</a:t>
+            </a:r>
+            <a:endParaRPr lang="en-US" sz="850" dirty="0"/>
+          </a:p>
+          <a:p>
+            <a:pPr marL="0" indent="0" algn="l">
+              <a:buNone/>
+            </a:pPr>
+            <a:r>
+              <a:rPr lang="en-US" sz="850" dirty="0">
+                <a:solidFill>
+                  <a:srgbClr val="1E3A8A"/>
+                </a:solidFill>
+                <a:latin typeface="Consolas" pitchFamily="34" charset="0"/>
+                <a:ea typeface="Consolas" pitchFamily="34" charset="-122"/>
+                <a:cs typeface="Consolas" pitchFamily="34" charset="-120"/>
+              </a:rPr>
+              <a:t>Select: smallest n  where  T(n)&lt;=targetTime  AND  Cost(n)&lt;=maxCost</a:t>
+            </a:r>
+            <a:endParaRPr lang="en-US" sz="850" dirty="0"/>
+          </a:p>
+        </p:txBody>
+      </p:sp>
+      <p:sp>
+        <p:nvSpPr>
+          <p:cNvPr id="30" name="Text 28">
+            <a:extLst>
+              <a:ext uri="{FF2B5EF4-FFF2-40B4-BE49-F238E27FC236}">
+                <a16:creationId xmlns:a16="http://schemas.microsoft.com/office/drawing/2014/main" id="{F3DE5BCD-E516-5286-F1CB-3F21803D5CCE}"/>
+              </a:ext>
+            </a:extLst>
+          </p:cNvPr>
+          <p:cNvSpPr/>
+          <p:nvPr/>
+        </p:nvSpPr>
+        <p:spPr>
+          <a:xfrm>
+            <a:off x="8503920" y="4846320"/>
+            <a:ext cx="548640" cy="201168"/>
+          </a:xfrm>
+          <a:prstGeom prst="rect">
+            <a:avLst/>
+          </a:prstGeom>
+          <a:noFill/>
+          <a:ln/>
+        </p:spPr>
+        <p:txBody>
+          <a:bodyPr wrap="square" lIns="0" tIns="0" rIns="0" bIns="0" rtlCol="0" anchor="ctr"/>
+          <a:lstStyle/>
+          <a:p>
+            <a:pPr marL="0" indent="0" algn="r">
+              <a:buNone/>
+            </a:pPr>
+            <a:r>
+              <a:rPr lang="en-US" sz="900" dirty="0">
+                <a:solidFill>
+                  <a:srgbClr val="64748B"/>
+                </a:solidFill>
+                <a:latin typeface="Calibri" pitchFamily="34" charset="0"/>
+                <a:ea typeface="Calibri" pitchFamily="34" charset="-122"/>
+                <a:cs typeface="Calibri" pitchFamily="34" charset="-120"/>
+              </a:rPr>
+              <a:t>7 / 10</a:t>
+            </a:r>
+            <a:endParaRPr lang="en-US" sz="900" dirty="0"/>
+          </a:p>
+        </p:txBody>
+      </p:sp>
+    </p:spTree>
+    <p:extLst>
+      <p:ext uri="{BB962C8B-B14F-4D97-AF65-F5344CB8AC3E}">
+        <p14:creationId xmlns:p14="http://schemas.microsoft.com/office/powerpoint/2010/main" val="1645484534"/>
+      </p:ext>
+    </p:extLst>
+  </p:cSld>
+  <p:clrMapOvr>
+    <a:masterClrMapping/>
+  </p:clrMapOvr>
+</p:sld>
+</file>
+
 <file path=ppt/slides/slide2.xml><?xml version="1.0" encoding="utf-8"?>
 <p:sld xmlns:a="http://schemas.openxmlformats.org/drawingml/2006/main" xmlns:r="http://schemas.openxmlformats.org/officeDocument/2006/relationships" xmlns:p="http://schemas.openxmlformats.org/presentationml/2006/main">
   <p:cSld name="Slide 2">
@@ -6118,7 +8438,7 @@
                 <a:ea typeface="Consolas" pitchFamily="34" charset="-122"/>
                 <a:cs typeface="Consolas" pitchFamily="34" charset="-120"/>
               </a:rPr>
-              <a:t>model:</a:t>
+              <a:t>  model:</a:t>
             </a:r>
             <a:endParaRPr lang="en-US" sz="700" dirty="0"/>
           </a:p>
@@ -9685,7 +12005,29 @@
                 <a:ea typeface="Calibri" pitchFamily="34" charset="-122"/>
                 <a:cs typeface="Calibri" pitchFamily="34" charset="-120"/>
               </a:rPr>
-              <a:t>Read DistributedJobHistory entries for this config hash; group by number of nodes, find average throughput P per node count.</a:t>
+              <a:t>Query </a:t>
+            </a:r>
+            <a:r>
+              <a:rPr lang="en-US" sz="875" dirty="0" err="1">
+                <a:solidFill>
+                  <a:srgbClr val="0F172A"/>
+                </a:solidFill>
+                <a:latin typeface="Calibri" pitchFamily="34" charset="0"/>
+                <a:ea typeface="Calibri" pitchFamily="34" charset="-122"/>
+                <a:cs typeface="Calibri" pitchFamily="34" charset="-120"/>
+              </a:rPr>
+              <a:t>DistributedJobHistory</a:t>
+            </a:r>
+            <a:r>
+              <a:rPr lang="en-US" sz="875" dirty="0">
+                <a:solidFill>
+                  <a:srgbClr val="0F172A"/>
+                </a:solidFill>
+                <a:latin typeface="Calibri" pitchFamily="34" charset="0"/>
+                <a:ea typeface="Calibri" pitchFamily="34" charset="-122"/>
+                <a:cs typeface="Calibri" pitchFamily="34" charset="-120"/>
+              </a:rPr>
+              <a:t> entries matching config hash; group by node count, find average throughput P per node count.</a:t>
             </a:r>
             <a:endParaRPr lang="en-US" sz="875" dirty="0"/>
           </a:p>
@@ -9866,7 +12208,7 @@
                 <a:ea typeface="Calibri" pitchFamily="34" charset="-122"/>
                 <a:cs typeface="Calibri" pitchFamily="34" charset="-120"/>
               </a:rPr>
-              <a:t>At minimum number of nodes, compute single-node throughput: P0 = P_min / </a:t>
+              <a:t>Compute single node throughput P0 = P_min / </a:t>
             </a:r>
             <a:r>
               <a:rPr lang="en-US" sz="875" dirty="0" err="1">
@@ -9888,7 +12230,29 @@
                 <a:ea typeface="Calibri" pitchFamily="34" charset="-122"/>
                 <a:cs typeface="Calibri" pitchFamily="34" charset="-120"/>
               </a:rPr>
-              <a:t>.</a:t>
+              <a:t>. Extract total work W and mean provisioning time </a:t>
+            </a:r>
+            <a:r>
+              <a:rPr lang="en-US" sz="875" dirty="0" err="1">
+                <a:solidFill>
+                  <a:srgbClr val="0F172A"/>
+                </a:solidFill>
+                <a:latin typeface="Calibri" pitchFamily="34" charset="0"/>
+                <a:ea typeface="Calibri" pitchFamily="34" charset="-122"/>
+                <a:cs typeface="Calibri" pitchFamily="34" charset="-120"/>
+              </a:rPr>
+              <a:t>t_prov</a:t>
+            </a:r>
+            <a:r>
+              <a:rPr lang="en-US" sz="875" dirty="0">
+                <a:solidFill>
+                  <a:srgbClr val="0F172A"/>
+                </a:solidFill>
+                <a:latin typeface="Calibri" pitchFamily="34" charset="0"/>
+                <a:ea typeface="Calibri" pitchFamily="34" charset="-122"/>
+                <a:cs typeface="Calibri" pitchFamily="34" charset="-120"/>
+              </a:rPr>
+              <a:t> for the prediction.</a:t>
             </a:r>
             <a:endParaRPr lang="en-US" sz="875" dirty="0"/>
           </a:p>
@@ -10069,7 +12433,7 @@
                 <a:ea typeface="Calibri" pitchFamily="34" charset="-122"/>
                 <a:cs typeface="Calibri" pitchFamily="34" charset="-120"/>
               </a:rPr>
-              <a:t>Model efficiency decay η(n)=1/(1+α(n-1)). Closed-form for 2 history entries; golden-section search for 3+.</a:t>
+              <a:t>Efficiency model decay η(n)=1/(1+α(n-1)). Closed-form for 2 history entries; golden-section search for 3+ history entries.</a:t>
             </a:r>
             <a:endParaRPr lang="en-US" sz="875" dirty="0"/>
           </a:p>
@@ -10083,8 +12447,8 @@
         </p:nvSpPr>
         <p:spPr>
           <a:xfrm>
-            <a:off x="133973" y="4573729"/>
-            <a:ext cx="4020000" cy="510000"/>
+            <a:off x="133973" y="4573728"/>
+            <a:ext cx="4020000" cy="569771"/>
           </a:xfrm>
           <a:prstGeom prst="rect">
             <a:avLst/>
@@ -10116,7 +12480,7 @@
         <p:spPr>
           <a:xfrm>
             <a:off x="133568" y="4567577"/>
-            <a:ext cx="307982" cy="510000"/>
+            <a:ext cx="307982" cy="564962"/>
           </a:xfrm>
           <a:prstGeom prst="rect">
             <a:avLst/>
@@ -10211,7 +12575,7 @@
                 <a:ea typeface="Calibri" pitchFamily="34" charset="-122"/>
                 <a:cs typeface="Calibri" pitchFamily="34" charset="-120"/>
               </a:rPr>
-              <a:t>Select Optimal Number of Nodes N </a:t>
+              <a:t>Select Optimal Number of Nodes </a:t>
             </a:r>
             <a:endParaRPr lang="en-US" sz="1050" dirty="0"/>
           </a:p>
@@ -10226,7 +12590,7 @@
         <p:spPr>
           <a:xfrm>
             <a:off x="475020" y="4737810"/>
-            <a:ext cx="3660000" cy="265000"/>
+            <a:ext cx="3652539" cy="265000"/>
           </a:xfrm>
           <a:prstGeom prst="rect">
             <a:avLst/>
@@ -10238,9 +12602,6 @@
           <a:bodyPr wrap="square" lIns="0" tIns="0" rIns="0" bIns="0" rtlCol="0" anchor="t"/>
           <a:lstStyle/>
           <a:p>
-            <a:pPr marL="0" indent="0" algn="l">
-              <a:buNone/>
-            </a:pPr>
             <a:r>
               <a:rPr lang="en-US" sz="875" dirty="0">
                 <a:solidFill>
@@ -10250,7 +12611,51 @@
                 <a:ea typeface="Calibri" pitchFamily="34" charset="-122"/>
                 <a:cs typeface="Calibri" pitchFamily="34" charset="-120"/>
               </a:rPr>
-              <a:t>Evaluate predicted T(n) and Cost(n) per candidate; return smallest n satisfying the Objective.</a:t>
+              <a:t>Evaluate T(n) and Cost(n) per candidate; pick smallest n meeting </a:t>
+            </a:r>
+            <a:r>
+              <a:rPr lang="en-US" sz="875" dirty="0" err="1">
+                <a:solidFill>
+                  <a:srgbClr val="0F172A"/>
+                </a:solidFill>
+                <a:latin typeface="Calibri" pitchFamily="34" charset="0"/>
+                <a:ea typeface="Calibri" pitchFamily="34" charset="-122"/>
+                <a:cs typeface="Calibri" pitchFamily="34" charset="-120"/>
+              </a:rPr>
+              <a:t>targetTime</a:t>
+            </a:r>
+            <a:r>
+              <a:rPr lang="en-US" sz="875" dirty="0">
+                <a:solidFill>
+                  <a:srgbClr val="0F172A"/>
+                </a:solidFill>
+                <a:latin typeface="Calibri" pitchFamily="34" charset="0"/>
+                <a:ea typeface="Calibri" pitchFamily="34" charset="-122"/>
+                <a:cs typeface="Calibri" pitchFamily="34" charset="-120"/>
+              </a:rPr>
+              <a:t>, the largest n within </a:t>
+            </a:r>
+            <a:r>
+              <a:rPr lang="en-US" sz="875" dirty="0" err="1">
+                <a:solidFill>
+                  <a:srgbClr val="0F172A"/>
+                </a:solidFill>
+                <a:latin typeface="Calibri" pitchFamily="34" charset="0"/>
+                <a:ea typeface="Calibri" pitchFamily="34" charset="-122"/>
+                <a:cs typeface="Calibri" pitchFamily="34" charset="-120"/>
+              </a:rPr>
+              <a:t>maxCost</a:t>
+            </a:r>
+            <a:r>
+              <a:rPr lang="en-US" sz="875" dirty="0">
+                <a:solidFill>
+                  <a:srgbClr val="0F172A"/>
+                </a:solidFill>
+                <a:latin typeface="Calibri" pitchFamily="34" charset="0"/>
+                <a:ea typeface="Calibri" pitchFamily="34" charset="-122"/>
+                <a:cs typeface="Calibri" pitchFamily="34" charset="-120"/>
+              </a:rPr>
+              <a:t>, or when both given, satisfy time first then reduce n until cost fits.</a:t>
             </a:r>
             <a:endParaRPr lang="en-US" sz="875" dirty="0"/>
           </a:p>
@@ -14314,7 +16719,7 @@
                 <a:ea typeface="Calibri" pitchFamily="34" charset="-122"/>
                 <a:cs typeface="Calibri" pitchFamily="34" charset="-120"/>
               </a:rPr>
-              <a:t>Two calibrations give sub-7% time prediction. By run A3 error is &lt;3%. Alpha stabilizes as history grows.</a:t>
+              <a:t>Two calibrations give sub-7% time prediction. Alpha stabilizes as history grows.</a:t>
             </a:r>
             <a:endParaRPr lang="en-US" sz="1000" dirty="0"/>
           </a:p>
@@ -14495,7 +16900,7 @@
                 <a:ea typeface="Calibri" pitchFamily="34" charset="-122"/>
                 <a:cs typeface="Calibri" pitchFamily="34" charset="-120"/>
               </a:rPr>
-              <a:t>User declares a time/cost objective; tuner computes N from historical data.</a:t>
+              <a:t>User declares a time/cost objective; tuner computes number of nodes from historical data.</a:t>
             </a:r>
             <a:endParaRPr lang="en-US" sz="1000" dirty="0"/>
           </a:p>
@@ -14637,7 +17042,7 @@
                 <a:ea typeface="Calibri" pitchFamily="34" charset="-122"/>
                 <a:cs typeface="Calibri" pitchFamily="34" charset="-120"/>
               </a:rPr>
-              <a:t>Constant-α model</a:t>
+              <a:t>Constant-α model assumption</a:t>
             </a:r>
             <a:endParaRPr lang="en-US" sz="1000" dirty="0"/>
           </a:p>
@@ -16215,9 +18620,6 @@
           <a:bodyPr wrap="square" lIns="0" tIns="0" rIns="0" bIns="0" rtlCol="0" anchor="ctr"/>
           <a:lstStyle/>
           <a:p>
-            <a:pPr marL="0" indent="0" algn="l">
-              <a:buNone/>
-            </a:pPr>
             <a:r>
               <a:rPr lang="en-US" sz="1300" dirty="0">
                 <a:solidFill>
@@ -16227,7 +18629,7 @@
                 <a:ea typeface="Calibri" pitchFamily="34" charset="-122"/>
                 <a:cs typeface="Calibri" pitchFamily="34" charset="-120"/>
               </a:rPr>
-              <a:t>Source code: github.com/JonMukaj/distributed-job-operator</a:t>
+              <a:t>Source code: github.com/JonMukaj/distributed-training-operator</a:t>
             </a:r>
             <a:endParaRPr lang="en-US" sz="1300" dirty="0"/>
           </a:p>
@@ -16269,6 +18671,374 @@
               <a:t>Jon Mukaj  ·  Praktikum 2  ·  Supervisor: Prof. Enes Bajrovic</a:t>
             </a:r>
             <a:endParaRPr lang="en-US" sz="1300" dirty="0"/>
+          </a:p>
+        </p:txBody>
+      </p:sp>
+    </p:spTree>
+  </p:cSld>
+  <p:clrMapOvr>
+    <a:masterClrMapping/>
+  </p:clrMapOvr>
+</p:sld>
+</file>
+
+<file path=ppt/slides/slide9.xml><?xml version="1.0" encoding="utf-8"?>
+<p:sld xmlns:a="http://schemas.openxmlformats.org/drawingml/2006/main" xmlns:r="http://schemas.openxmlformats.org/officeDocument/2006/relationships" xmlns:p="http://schemas.openxmlformats.org/presentationml/2006/main">
+  <p:cSld>
+    <p:spTree>
+      <p:nvGrpSpPr>
+        <p:cNvPr id="1" name=""/>
+        <p:cNvGrpSpPr/>
+        <p:nvPr/>
+      </p:nvGrpSpPr>
+      <p:grpSpPr>
+        <a:xfrm>
+          <a:off x="0" y="0"/>
+          <a:ext cx="0" cy="0"/>
+          <a:chOff x="0" y="0"/>
+          <a:chExt cx="0" cy="0"/>
+        </a:xfrm>
+      </p:grpSpPr>
+      <p:sp>
+        <p:nvSpPr>
+          <p:cNvPr id="2" name="Text 0"/>
+          <p:cNvSpPr/>
+          <p:nvPr/>
+        </p:nvSpPr>
+        <p:spPr>
+          <a:xfrm>
+            <a:off x="502920" y="274320"/>
+            <a:ext cx="8138160" cy="640080"/>
+          </a:xfrm>
+          <a:prstGeom prst="rect">
+            <a:avLst/>
+          </a:prstGeom>
+          <a:noFill/>
+          <a:ln/>
+        </p:spPr>
+        <p:txBody>
+          <a:bodyPr wrap="square" lIns="0" tIns="0" rIns="0" bIns="0" rtlCol="0" anchor="ctr"/>
+          <a:lstStyle/>
+          <a:p>
+            <a:pPr marL="0" indent="0" algn="l">
+              <a:buNone/>
+            </a:pPr>
+            <a:r>
+              <a:rPr lang="en-US" sz="3200" b="1" dirty="0">
+                <a:solidFill>
+                  <a:srgbClr val="1E3A8A"/>
+                </a:solidFill>
+                <a:latin typeface="Calibri" pitchFamily="34" charset="0"/>
+                <a:ea typeface="Calibri" pitchFamily="34" charset="-122"/>
+                <a:cs typeface="Calibri" pitchFamily="34" charset="-120"/>
+              </a:rPr>
+              <a:t>What Is a Kubernetes Operator?</a:t>
+            </a:r>
+            <a:endParaRPr lang="en-US" sz="3200" dirty="0"/>
+          </a:p>
+        </p:txBody>
+      </p:sp>
+      <p:sp>
+        <p:nvSpPr>
+          <p:cNvPr id="3" name="Shape 1"/>
+          <p:cNvSpPr/>
+          <p:nvPr/>
+        </p:nvSpPr>
+        <p:spPr>
+          <a:xfrm>
+            <a:off x="502920" y="932688"/>
+            <a:ext cx="8138160" cy="27432"/>
+          </a:xfrm>
+          <a:prstGeom prst="rect">
+            <a:avLst/>
+          </a:prstGeom>
+          <a:solidFill>
+            <a:srgbClr val="3B82F6"/>
+          </a:solidFill>
+          <a:ln w="12700">
+            <a:solidFill>
+              <a:srgbClr val="3B82F6"/>
+            </a:solidFill>
+            <a:prstDash val="solid"/>
+          </a:ln>
+        </p:spPr>
+        <p:txBody>
+          <a:bodyPr/>
+          <a:lstStyle/>
+          <a:p>
+            <a:endParaRPr lang="en-US"/>
+          </a:p>
+        </p:txBody>
+      </p:sp>
+      <p:sp>
+        <p:nvSpPr>
+          <p:cNvPr id="4" name="Text 2"/>
+          <p:cNvSpPr/>
+          <p:nvPr/>
+        </p:nvSpPr>
+        <p:spPr>
+          <a:xfrm>
+            <a:off x="399098" y="1459733"/>
+            <a:ext cx="4297680" cy="685800"/>
+          </a:xfrm>
+          <a:prstGeom prst="rect">
+            <a:avLst/>
+          </a:prstGeom>
+          <a:noFill/>
+          <a:ln/>
+        </p:spPr>
+        <p:txBody>
+          <a:bodyPr wrap="square" lIns="0" tIns="0" rIns="0" bIns="0" rtlCol="0" anchor="ctr"/>
+          <a:lstStyle/>
+          <a:p>
+            <a:r>
+              <a:rPr lang="en-US" sz="1200" dirty="0"/>
+              <a:t>Kubernetes manages built-in resources (Pods, Services, Deployments). Operators extend it with custom types and operational logic.</a:t>
+            </a:r>
+          </a:p>
+        </p:txBody>
+      </p:sp>
+      <p:sp>
+        <p:nvSpPr>
+          <p:cNvPr id="5" name="Text 3"/>
+          <p:cNvSpPr/>
+          <p:nvPr/>
+        </p:nvSpPr>
+        <p:spPr>
+          <a:xfrm>
+            <a:off x="182881" y="2291184"/>
+            <a:ext cx="4297680" cy="1828800"/>
+          </a:xfrm>
+          <a:prstGeom prst="rect">
+            <a:avLst/>
+          </a:prstGeom>
+          <a:noFill/>
+          <a:ln/>
+        </p:spPr>
+        <p:txBody>
+          <a:bodyPr wrap="square" lIns="0" tIns="0" rIns="0" bIns="0" rtlCol="0" anchor="t"/>
+          <a:lstStyle/>
+          <a:p>
+            <a:pPr marL="342900" indent="-342900" algn="l">
+              <a:spcAft>
+                <a:spcPts val="1200"/>
+              </a:spcAft>
+              <a:buSzPct val="100000"/>
+              <a:buChar char="•"/>
+            </a:pPr>
+            <a:r>
+              <a:rPr lang="en-US" sz="1200" dirty="0">
+                <a:solidFill>
+                  <a:srgbClr val="0F172A"/>
+                </a:solidFill>
+                <a:latin typeface="Calibri" pitchFamily="34" charset="0"/>
+                <a:ea typeface="Calibri" pitchFamily="34" charset="-122"/>
+                <a:cs typeface="Calibri" pitchFamily="34" charset="-120"/>
+              </a:rPr>
+              <a:t>Operators extend the Kubernetes API by introducing new resource types (CRDs) the cluster understands natively.</a:t>
+            </a:r>
+            <a:endParaRPr lang="en-US" sz="1200" dirty="0"/>
+          </a:p>
+          <a:p>
+            <a:pPr marL="342900" indent="-342900">
+              <a:spcAft>
+                <a:spcPts val="1200"/>
+              </a:spcAft>
+              <a:buSzPct val="100000"/>
+              <a:buChar char="•"/>
+            </a:pPr>
+            <a:r>
+              <a:rPr lang="en-US" sz="1200" dirty="0"/>
+              <a:t>A CRD defines the schema for a custom resource, </a:t>
+            </a:r>
+            <a:r>
+              <a:rPr lang="en-US" sz="1200" dirty="0">
+                <a:solidFill>
+                  <a:srgbClr val="0F172A"/>
+                </a:solidFill>
+                <a:latin typeface="Calibri" pitchFamily="34" charset="0"/>
+                <a:ea typeface="Calibri" pitchFamily="34" charset="-122"/>
+                <a:cs typeface="Calibri" pitchFamily="34" charset="-120"/>
+              </a:rPr>
+              <a:t>the desired state (spec) and observed state (status).</a:t>
+            </a:r>
+          </a:p>
+          <a:p>
+            <a:pPr marL="342900" indent="-342900" algn="l">
+              <a:spcAft>
+                <a:spcPts val="1200"/>
+              </a:spcAft>
+              <a:buSzPct val="100000"/>
+              <a:buChar char="•"/>
+            </a:pPr>
+            <a:r>
+              <a:rPr lang="en-US" sz="1200" dirty="0">
+                <a:solidFill>
+                  <a:srgbClr val="0F172A"/>
+                </a:solidFill>
+                <a:latin typeface="Calibri" pitchFamily="34" charset="0"/>
+                <a:ea typeface="Calibri" pitchFamily="34" charset="-122"/>
+                <a:cs typeface="Calibri" pitchFamily="34" charset="-120"/>
+              </a:rPr>
+              <a:t>A Controller (</a:t>
+            </a:r>
+            <a:r>
+              <a:rPr lang="en-US" sz="1200" dirty="0" err="1">
+                <a:solidFill>
+                  <a:srgbClr val="0F172A"/>
+                </a:solidFill>
+                <a:latin typeface="Calibri" pitchFamily="34" charset="0"/>
+                <a:ea typeface="Calibri" pitchFamily="34" charset="-122"/>
+                <a:cs typeface="Calibri" pitchFamily="34" charset="-120"/>
+              </a:rPr>
+              <a:t>e.g</a:t>
+            </a:r>
+            <a:r>
+              <a:rPr lang="en-US" sz="1200" dirty="0">
+                <a:solidFill>
+                  <a:srgbClr val="0F172A"/>
+                </a:solidFill>
+                <a:latin typeface="Calibri" pitchFamily="34" charset="0"/>
+                <a:ea typeface="Calibri" pitchFamily="34" charset="-122"/>
+                <a:cs typeface="Calibri" pitchFamily="34" charset="-120"/>
+              </a:rPr>
+              <a:t> Deployment object) watches those resources and runs a reconcile loop, observe actual state, compare to desired, act to close the gap.</a:t>
+            </a:r>
+            <a:endParaRPr lang="en-US" sz="1200" dirty="0"/>
+          </a:p>
+        </p:txBody>
+      </p:sp>
+      <p:pic>
+        <p:nvPicPr>
+          <p:cNvPr id="6" name="Image 0" descr="/sessions/exciting-loving-carson/mnt/praktikum2/graphic_what-are-kubernetes-operators.png"/>
+          <p:cNvPicPr>
+            <a:picLocks noChangeAspect="1"/>
+          </p:cNvPicPr>
+          <p:nvPr/>
+        </p:nvPicPr>
+        <p:blipFill>
+          <a:blip r:embed="rId3"/>
+          <a:stretch>
+            <a:fillRect/>
+          </a:stretch>
+        </p:blipFill>
+        <p:spPr>
+          <a:xfrm>
+            <a:off x="4419600" y="1425614"/>
+            <a:ext cx="4632960" cy="2058542"/>
+          </a:xfrm>
+          <a:prstGeom prst="rect">
+            <a:avLst/>
+          </a:prstGeom>
+        </p:spPr>
+      </p:pic>
+      <p:sp>
+        <p:nvSpPr>
+          <p:cNvPr id="7" name="Shape 4"/>
+          <p:cNvSpPr/>
+          <p:nvPr/>
+        </p:nvSpPr>
+        <p:spPr>
+          <a:xfrm>
+            <a:off x="4663440" y="3653626"/>
+            <a:ext cx="4206240" cy="384048"/>
+          </a:xfrm>
+          <a:prstGeom prst="rect">
+            <a:avLst/>
+          </a:prstGeom>
+          <a:solidFill>
+            <a:srgbClr val="FEF9C3"/>
+          </a:solidFill>
+          <a:ln w="9525">
+            <a:solidFill>
+              <a:srgbClr val="EAB308"/>
+            </a:solidFill>
+            <a:prstDash val="solid"/>
+          </a:ln>
+        </p:spPr>
+        <p:txBody>
+          <a:bodyPr/>
+          <a:lstStyle/>
+          <a:p>
+            <a:endParaRPr lang="en-US"/>
+          </a:p>
+        </p:txBody>
+      </p:sp>
+      <p:sp>
+        <p:nvSpPr>
+          <p:cNvPr id="8" name="Text 5"/>
+          <p:cNvSpPr/>
+          <p:nvPr/>
+        </p:nvSpPr>
+        <p:spPr>
+          <a:xfrm>
+            <a:off x="4663440" y="3653626"/>
+            <a:ext cx="4206240" cy="384048"/>
+          </a:xfrm>
+          <a:prstGeom prst="rect">
+            <a:avLst/>
+          </a:prstGeom>
+          <a:noFill/>
+          <a:ln/>
+        </p:spPr>
+        <p:txBody>
+          <a:bodyPr wrap="square" lIns="50800" tIns="50800" rIns="50800" bIns="50800" rtlCol="0" anchor="ctr"/>
+          <a:lstStyle/>
+          <a:p>
+            <a:pPr marL="0" indent="0" algn="ctr">
+              <a:buNone/>
+            </a:pPr>
+            <a:r>
+              <a:rPr lang="en-US" sz="1000" i="1" dirty="0">
+                <a:solidFill>
+                  <a:srgbClr val="78350F"/>
+                </a:solidFill>
+                <a:latin typeface="Calibri" pitchFamily="34" charset="0"/>
+                <a:ea typeface="Calibri" pitchFamily="34" charset="-122"/>
+                <a:cs typeface="Calibri" pitchFamily="34" charset="-120"/>
+              </a:rPr>
+              <a:t>CRD + Controller = Operator Pattern</a:t>
+            </a:r>
+            <a:endParaRPr lang="en-US" sz="1000" dirty="0"/>
+          </a:p>
+        </p:txBody>
+      </p:sp>
+      <p:sp>
+        <p:nvSpPr>
+          <p:cNvPr id="9" name="Text 6"/>
+          <p:cNvSpPr/>
+          <p:nvPr/>
+        </p:nvSpPr>
+        <p:spPr>
+          <a:xfrm>
+            <a:off x="8503920" y="4846320"/>
+            <a:ext cx="548640" cy="201168"/>
+          </a:xfrm>
+          <a:prstGeom prst="rect">
+            <a:avLst/>
+          </a:prstGeom>
+          <a:noFill/>
+          <a:ln/>
+        </p:spPr>
+        <p:txBody>
+          <a:bodyPr wrap="square" lIns="0" tIns="0" rIns="0" bIns="0" rtlCol="0" anchor="ctr"/>
+          <a:lstStyle/>
+          <a:p>
+            <a:pPr marL="0" indent="0" algn="r">
+              <a:buNone/>
+            </a:pPr>
+            <a:r>
+              <a:rPr lang="en-US" sz="900" dirty="0">
+                <a:solidFill>
+                  <a:srgbClr val="64748B"/>
+                </a:solidFill>
+                <a:latin typeface="Calibri" pitchFamily="34" charset="0"/>
+                <a:ea typeface="Calibri" pitchFamily="34" charset="-122"/>
+                <a:cs typeface="Calibri" pitchFamily="34" charset="-120"/>
+              </a:rPr>
+              <a:t>2 / 10</a:t>
+            </a:r>
+            <a:endParaRPr lang="en-US" sz="900" dirty="0"/>
           </a:p>
         </p:txBody>
       </p:sp>

</xml_diff>